<commit_message>
feat(pptx): add Agentic Engineering slide, fixed price language
- New slide: Agentic Engineering vs AI-assisted development
- "Agents do the work. Humans set the direction."
- "Fixed price per delivery. No rates. No surprises."
- Updated closing quote

Co-Authored-By: Claude Opus 4.5 <noreply@anthropic.com>
</commit_message>
<xml_diff>
--- a/docs/STARK_Procurement_Scope_Brief_Kim_Christensen.pptx
+++ b/docs/STARK_Procurement_Scope_Brief_Kim_Christensen.pptx
@@ -5,35 +5,36 @@
     <p:sldMasterId id="2147483648" r:id="rId1"/>
   </p:sldMasterIdLst>
   <p:sldIdLst>
-    <p:sldId id="256" r:id="rId2"/>
-    <p:sldId id="257" r:id="rId3"/>
-    <p:sldId id="258" r:id="rId4"/>
-    <p:sldId id="259" r:id="rId5"/>
-    <p:sldId id="260" r:id="rId6"/>
-    <p:sldId id="261" r:id="rId7"/>
-    <p:sldId id="262" r:id="rId8"/>
-    <p:sldId id="263" r:id="rId9"/>
-    <p:sldId id="264" r:id="rId10"/>
-    <p:sldId id="265" r:id="rId11"/>
-    <p:sldId id="266" r:id="rId12"/>
-    <p:sldId id="267" r:id="rId13"/>
-    <p:sldId id="268" r:id="rId14"/>
-    <p:sldId id="269" r:id="rId15"/>
-    <p:sldId id="270" r:id="rId16"/>
-    <p:sldId id="271" r:id="rId17"/>
-    <p:sldId id="272" r:id="rId18"/>
-    <p:sldId id="273" r:id="rId19"/>
-    <p:sldId id="274" r:id="rId20"/>
-    <p:sldId id="275" r:id="rId21"/>
-    <p:sldId id="276" r:id="rId22"/>
-    <p:sldId id="277" r:id="rId23"/>
-    <p:sldId id="278" r:id="rId24"/>
-    <p:sldId id="279" r:id="rId25"/>
-    <p:sldId id="280" r:id="rId26"/>
-    <p:sldId id="281" r:id="rId27"/>
-    <p:sldId id="282" r:id="rId28"/>
+    <p:sldId id="256" r:id="rId7"/>
+    <p:sldId id="257" r:id="rId8"/>
+    <p:sldId id="258" r:id="rId9"/>
+    <p:sldId id="259" r:id="rId10"/>
+    <p:sldId id="260" r:id="rId11"/>
+    <p:sldId id="261" r:id="rId12"/>
+    <p:sldId id="262" r:id="rId13"/>
+    <p:sldId id="263" r:id="rId14"/>
+    <p:sldId id="264" r:id="rId15"/>
+    <p:sldId id="265" r:id="rId16"/>
+    <p:sldId id="266" r:id="rId17"/>
+    <p:sldId id="267" r:id="rId18"/>
+    <p:sldId id="268" r:id="rId19"/>
+    <p:sldId id="269" r:id="rId20"/>
+    <p:sldId id="270" r:id="rId21"/>
+    <p:sldId id="271" r:id="rId22"/>
+    <p:sldId id="272" r:id="rId23"/>
+    <p:sldId id="273" r:id="rId24"/>
+    <p:sldId id="274" r:id="rId25"/>
+    <p:sldId id="275" r:id="rId26"/>
+    <p:sldId id="276" r:id="rId27"/>
+    <p:sldId id="277" r:id="rId28"/>
+    <p:sldId id="278" r:id="rId29"/>
+    <p:sldId id="279" r:id="rId30"/>
+    <p:sldId id="280" r:id="rId31"/>
+    <p:sldId id="281" r:id="rId32"/>
+    <p:sldId id="282" r:id="rId33"/>
+    <p:sldId id="283" r:id="rId34"/>
   </p:sldIdLst>
-  <p:sldSz cx="12192000" cy="6858000"/>
+  <p:sldSz cx="12191695" cy="6858000" type="screen4x3"/>
   <p:notesSz cx="6858000" cy="9144000"/>
   <p:defaultTextStyle>
     <a:defPPr>
@@ -130,22 +131,6 @@
       </a:defRPr>
     </a:lvl9pPr>
   </p:defaultTextStyle>
-  <p:extLst>
-    <p:ext uri="{EFAFB233-063F-42B5-8137-9DF3F51BA10A}">
-      <p15:sldGuideLst xmlns:p15="http://schemas.microsoft.com/office/powerpoint/2012/main">
-        <p15:guide id="1" orient="horz" pos="2160">
-          <p15:clr>
-            <a:srgbClr val="A4A3A4"/>
-          </p15:clr>
-        </p15:guide>
-        <p15:guide id="2" pos="2880">
-          <p15:clr>
-            <a:srgbClr val="A4A3A4"/>
-          </p15:clr>
-        </p15:guide>
-      </p15:sldGuideLst>
-    </p:ext>
-  </p:extLst>
 </p:presentation>
 </file>
 
@@ -187,9 +172,10 @@
           <a:lstStyle/>
           <a:p>
             <a:r>
-              <a:rPr lang="en-US"/>
+              <a:rPr lang="en-US" smtClean="0"/>
               <a:t>Click to edit Master title style</a:t>
             </a:r>
+            <a:endParaRPr lang="en-US"/>
           </a:p>
         </p:txBody>
       </p:sp>
@@ -305,9 +291,10 @@
           </a:lstStyle>
           <a:p>
             <a:r>
-              <a:rPr lang="en-US"/>
+              <a:rPr lang="en-US" smtClean="0"/>
               <a:t>Click to edit Master subtitle style</a:t>
             </a:r>
+            <a:endParaRPr lang="en-US"/>
           </a:p>
         </p:txBody>
       </p:sp>
@@ -328,7 +315,7 @@
           <a:p>
             <a:fld id="{5BCAD085-E8A6-8845-BD4E-CB4CCA059FC4}" type="datetimeFigureOut">
               <a:rPr lang="en-US" smtClean="0"/>
-              <a:t>3/23/26</a:t>
+              <a:t>1/27/13</a:t>
             </a:fld>
             <a:endParaRPr lang="en-US"/>
           </a:p>
@@ -422,9 +409,10 @@
           <a:lstStyle/>
           <a:p>
             <a:r>
-              <a:rPr lang="en-US"/>
+              <a:rPr lang="en-US" smtClean="0"/>
               <a:t>Click to edit Master title style</a:t>
             </a:r>
+            <a:endParaRPr lang="en-US"/>
           </a:p>
         </p:txBody>
       </p:sp>
@@ -445,37 +433,38 @@
           <a:p>
             <a:pPr lvl="0"/>
             <a:r>
-              <a:rPr lang="en-US"/>
+              <a:rPr lang="en-US" smtClean="0"/>
               <a:t>Click to edit Master text styles</a:t>
             </a:r>
           </a:p>
           <a:p>
             <a:pPr lvl="1"/>
             <a:r>
-              <a:rPr lang="en-US"/>
+              <a:rPr lang="en-US" smtClean="0"/>
               <a:t>Second level</a:t>
             </a:r>
           </a:p>
           <a:p>
             <a:pPr lvl="2"/>
             <a:r>
-              <a:rPr lang="en-US"/>
+              <a:rPr lang="en-US" smtClean="0"/>
               <a:t>Third level</a:t>
             </a:r>
           </a:p>
           <a:p>
             <a:pPr lvl="3"/>
             <a:r>
-              <a:rPr lang="en-US"/>
+              <a:rPr lang="en-US" smtClean="0"/>
               <a:t>Fourth level</a:t>
             </a:r>
           </a:p>
           <a:p>
             <a:pPr lvl="4"/>
             <a:r>
-              <a:rPr lang="en-US"/>
+              <a:rPr lang="en-US" smtClean="0"/>
               <a:t>Fifth level</a:t>
             </a:r>
+            <a:endParaRPr lang="en-US"/>
           </a:p>
         </p:txBody>
       </p:sp>
@@ -496,7 +485,7 @@
           <a:p>
             <a:fld id="{5BCAD085-E8A6-8845-BD4E-CB4CCA059FC4}" type="datetimeFigureOut">
               <a:rPr lang="en-US" smtClean="0"/>
-              <a:t>3/23/26</a:t>
+              <a:t>1/27/13</a:t>
             </a:fld>
             <a:endParaRPr lang="en-US"/>
           </a:p>
@@ -595,9 +584,10 @@
           <a:lstStyle/>
           <a:p>
             <a:r>
-              <a:rPr lang="en-US"/>
+              <a:rPr lang="en-US" smtClean="0"/>
               <a:t>Click to edit Master title style</a:t>
             </a:r>
+            <a:endParaRPr lang="en-US"/>
           </a:p>
         </p:txBody>
       </p:sp>
@@ -623,37 +613,38 @@
           <a:p>
             <a:pPr lvl="0"/>
             <a:r>
-              <a:rPr lang="en-US"/>
+              <a:rPr lang="en-US" smtClean="0"/>
               <a:t>Click to edit Master text styles</a:t>
             </a:r>
           </a:p>
           <a:p>
             <a:pPr lvl="1"/>
             <a:r>
-              <a:rPr lang="en-US"/>
+              <a:rPr lang="en-US" smtClean="0"/>
               <a:t>Second level</a:t>
             </a:r>
           </a:p>
           <a:p>
             <a:pPr lvl="2"/>
             <a:r>
-              <a:rPr lang="en-US"/>
+              <a:rPr lang="en-US" smtClean="0"/>
               <a:t>Third level</a:t>
             </a:r>
           </a:p>
           <a:p>
             <a:pPr lvl="3"/>
             <a:r>
-              <a:rPr lang="en-US"/>
+              <a:rPr lang="en-US" smtClean="0"/>
               <a:t>Fourth level</a:t>
             </a:r>
           </a:p>
           <a:p>
             <a:pPr lvl="4"/>
             <a:r>
-              <a:rPr lang="en-US"/>
+              <a:rPr lang="en-US" smtClean="0"/>
               <a:t>Fifth level</a:t>
             </a:r>
+            <a:endParaRPr lang="en-US"/>
           </a:p>
         </p:txBody>
       </p:sp>
@@ -674,7 +665,7 @@
           <a:p>
             <a:fld id="{5BCAD085-E8A6-8845-BD4E-CB4CCA059FC4}" type="datetimeFigureOut">
               <a:rPr lang="en-US" smtClean="0"/>
-              <a:t>3/23/26</a:t>
+              <a:t>1/27/13</a:t>
             </a:fld>
             <a:endParaRPr lang="en-US"/>
           </a:p>
@@ -768,9 +759,10 @@
           <a:lstStyle/>
           <a:p>
             <a:r>
-              <a:rPr lang="en-US"/>
+              <a:rPr lang="en-US" smtClean="0"/>
               <a:t>Click to edit Master title style</a:t>
             </a:r>
+            <a:endParaRPr lang="en-US"/>
           </a:p>
         </p:txBody>
       </p:sp>
@@ -791,37 +783,38 @@
           <a:p>
             <a:pPr lvl="0"/>
             <a:r>
-              <a:rPr lang="en-US"/>
+              <a:rPr lang="en-US" smtClean="0"/>
               <a:t>Click to edit Master text styles</a:t>
             </a:r>
           </a:p>
           <a:p>
             <a:pPr lvl="1"/>
             <a:r>
-              <a:rPr lang="en-US"/>
+              <a:rPr lang="en-US" smtClean="0"/>
               <a:t>Second level</a:t>
             </a:r>
           </a:p>
           <a:p>
             <a:pPr lvl="2"/>
             <a:r>
-              <a:rPr lang="en-US"/>
+              <a:rPr lang="en-US" smtClean="0"/>
               <a:t>Third level</a:t>
             </a:r>
           </a:p>
           <a:p>
             <a:pPr lvl="3"/>
             <a:r>
-              <a:rPr lang="en-US"/>
+              <a:rPr lang="en-US" smtClean="0"/>
               <a:t>Fourth level</a:t>
             </a:r>
           </a:p>
           <a:p>
             <a:pPr lvl="4"/>
             <a:r>
-              <a:rPr lang="en-US"/>
+              <a:rPr lang="en-US" smtClean="0"/>
               <a:t>Fifth level</a:t>
             </a:r>
+            <a:endParaRPr lang="en-US"/>
           </a:p>
         </p:txBody>
       </p:sp>
@@ -842,7 +835,7 @@
           <a:p>
             <a:fld id="{5BCAD085-E8A6-8845-BD4E-CB4CCA059FC4}" type="datetimeFigureOut">
               <a:rPr lang="en-US" smtClean="0"/>
-              <a:t>3/23/26</a:t>
+              <a:t>1/27/13</a:t>
             </a:fld>
             <a:endParaRPr lang="en-US"/>
           </a:p>
@@ -945,9 +938,10 @@
           </a:lstStyle>
           <a:p>
             <a:r>
-              <a:rPr lang="en-US"/>
+              <a:rPr lang="en-US" smtClean="0"/>
               <a:t>Click to edit Master title style</a:t>
             </a:r>
+            <a:endParaRPr lang="en-US"/>
           </a:p>
         </p:txBody>
       </p:sp>
@@ -1064,7 +1058,7 @@
           <a:p>
             <a:pPr lvl="0"/>
             <a:r>
-              <a:rPr lang="en-US"/>
+              <a:rPr lang="en-US" smtClean="0"/>
               <a:t>Click to edit Master text styles</a:t>
             </a:r>
           </a:p>
@@ -1087,7 +1081,7 @@
           <a:p>
             <a:fld id="{5BCAD085-E8A6-8845-BD4E-CB4CCA059FC4}" type="datetimeFigureOut">
               <a:rPr lang="en-US" smtClean="0"/>
-              <a:t>3/23/26</a:t>
+              <a:t>1/27/13</a:t>
             </a:fld>
             <a:endParaRPr lang="en-US"/>
           </a:p>
@@ -1181,9 +1175,10 @@
           <a:lstStyle/>
           <a:p>
             <a:r>
-              <a:rPr lang="en-US"/>
+              <a:rPr lang="en-US" smtClean="0"/>
               <a:t>Click to edit Master title style</a:t>
             </a:r>
+            <a:endParaRPr lang="en-US"/>
           </a:p>
         </p:txBody>
       </p:sp>
@@ -1237,37 +1232,38 @@
           <a:p>
             <a:pPr lvl="0"/>
             <a:r>
-              <a:rPr lang="en-US"/>
+              <a:rPr lang="en-US" smtClean="0"/>
               <a:t>Click to edit Master text styles</a:t>
             </a:r>
           </a:p>
           <a:p>
             <a:pPr lvl="1"/>
             <a:r>
-              <a:rPr lang="en-US"/>
+              <a:rPr lang="en-US" smtClean="0"/>
               <a:t>Second level</a:t>
             </a:r>
           </a:p>
           <a:p>
             <a:pPr lvl="2"/>
             <a:r>
-              <a:rPr lang="en-US"/>
+              <a:rPr lang="en-US" smtClean="0"/>
               <a:t>Third level</a:t>
             </a:r>
           </a:p>
           <a:p>
             <a:pPr lvl="3"/>
             <a:r>
-              <a:rPr lang="en-US"/>
+              <a:rPr lang="en-US" smtClean="0"/>
               <a:t>Fourth level</a:t>
             </a:r>
           </a:p>
           <a:p>
             <a:pPr lvl="4"/>
             <a:r>
-              <a:rPr lang="en-US"/>
+              <a:rPr lang="en-US" smtClean="0"/>
               <a:t>Fifth level</a:t>
             </a:r>
+            <a:endParaRPr lang="en-US"/>
           </a:p>
         </p:txBody>
       </p:sp>
@@ -1321,37 +1317,38 @@
           <a:p>
             <a:pPr lvl="0"/>
             <a:r>
-              <a:rPr lang="en-US"/>
+              <a:rPr lang="en-US" smtClean="0"/>
               <a:t>Click to edit Master text styles</a:t>
             </a:r>
           </a:p>
           <a:p>
             <a:pPr lvl="1"/>
             <a:r>
-              <a:rPr lang="en-US"/>
+              <a:rPr lang="en-US" smtClean="0"/>
               <a:t>Second level</a:t>
             </a:r>
           </a:p>
           <a:p>
             <a:pPr lvl="2"/>
             <a:r>
-              <a:rPr lang="en-US"/>
+              <a:rPr lang="en-US" smtClean="0"/>
               <a:t>Third level</a:t>
             </a:r>
           </a:p>
           <a:p>
             <a:pPr lvl="3"/>
             <a:r>
-              <a:rPr lang="en-US"/>
+              <a:rPr lang="en-US" smtClean="0"/>
               <a:t>Fourth level</a:t>
             </a:r>
           </a:p>
           <a:p>
             <a:pPr lvl="4"/>
             <a:r>
-              <a:rPr lang="en-US"/>
+              <a:rPr lang="en-US" smtClean="0"/>
               <a:t>Fifth level</a:t>
             </a:r>
+            <a:endParaRPr lang="en-US"/>
           </a:p>
         </p:txBody>
       </p:sp>
@@ -1372,7 +1369,7 @@
           <a:p>
             <a:fld id="{5BCAD085-E8A6-8845-BD4E-CB4CCA059FC4}" type="datetimeFigureOut">
               <a:rPr lang="en-US" smtClean="0"/>
-              <a:t>3/23/26</a:t>
+              <a:t>1/27/13</a:t>
             </a:fld>
             <a:endParaRPr lang="en-US"/>
           </a:p>
@@ -1470,9 +1467,10 @@
           </a:lstStyle>
           <a:p>
             <a:r>
-              <a:rPr lang="en-US"/>
+              <a:rPr lang="en-US" smtClean="0"/>
               <a:t>Click to edit Master title style</a:t>
             </a:r>
+            <a:endParaRPr lang="en-US"/>
           </a:p>
         </p:txBody>
       </p:sp>
@@ -1535,7 +1533,7 @@
           <a:p>
             <a:pPr lvl="0"/>
             <a:r>
-              <a:rPr lang="en-US"/>
+              <a:rPr lang="en-US" smtClean="0"/>
               <a:t>Click to edit Master text styles</a:t>
             </a:r>
           </a:p>
@@ -1591,37 +1589,38 @@
           <a:p>
             <a:pPr lvl="0"/>
             <a:r>
-              <a:rPr lang="en-US"/>
+              <a:rPr lang="en-US" smtClean="0"/>
               <a:t>Click to edit Master text styles</a:t>
             </a:r>
           </a:p>
           <a:p>
             <a:pPr lvl="1"/>
             <a:r>
-              <a:rPr lang="en-US"/>
+              <a:rPr lang="en-US" smtClean="0"/>
               <a:t>Second level</a:t>
             </a:r>
           </a:p>
           <a:p>
             <a:pPr lvl="2"/>
             <a:r>
-              <a:rPr lang="en-US"/>
+              <a:rPr lang="en-US" smtClean="0"/>
               <a:t>Third level</a:t>
             </a:r>
           </a:p>
           <a:p>
             <a:pPr lvl="3"/>
             <a:r>
-              <a:rPr lang="en-US"/>
+              <a:rPr lang="en-US" smtClean="0"/>
               <a:t>Fourth level</a:t>
             </a:r>
           </a:p>
           <a:p>
             <a:pPr lvl="4"/>
             <a:r>
-              <a:rPr lang="en-US"/>
+              <a:rPr lang="en-US" smtClean="0"/>
               <a:t>Fifth level</a:t>
             </a:r>
+            <a:endParaRPr lang="en-US"/>
           </a:p>
         </p:txBody>
       </p:sp>
@@ -1684,7 +1683,7 @@
           <a:p>
             <a:pPr lvl="0"/>
             <a:r>
-              <a:rPr lang="en-US"/>
+              <a:rPr lang="en-US" smtClean="0"/>
               <a:t>Click to edit Master text styles</a:t>
             </a:r>
           </a:p>
@@ -1740,37 +1739,38 @@
           <a:p>
             <a:pPr lvl="0"/>
             <a:r>
-              <a:rPr lang="en-US"/>
+              <a:rPr lang="en-US" smtClean="0"/>
               <a:t>Click to edit Master text styles</a:t>
             </a:r>
           </a:p>
           <a:p>
             <a:pPr lvl="1"/>
             <a:r>
-              <a:rPr lang="en-US"/>
+              <a:rPr lang="en-US" smtClean="0"/>
               <a:t>Second level</a:t>
             </a:r>
           </a:p>
           <a:p>
             <a:pPr lvl="2"/>
             <a:r>
-              <a:rPr lang="en-US"/>
+              <a:rPr lang="en-US" smtClean="0"/>
               <a:t>Third level</a:t>
             </a:r>
           </a:p>
           <a:p>
             <a:pPr lvl="3"/>
             <a:r>
-              <a:rPr lang="en-US"/>
+              <a:rPr lang="en-US" smtClean="0"/>
               <a:t>Fourth level</a:t>
             </a:r>
           </a:p>
           <a:p>
             <a:pPr lvl="4"/>
             <a:r>
-              <a:rPr lang="en-US"/>
+              <a:rPr lang="en-US" smtClean="0"/>
               <a:t>Fifth level</a:t>
             </a:r>
+            <a:endParaRPr lang="en-US"/>
           </a:p>
         </p:txBody>
       </p:sp>
@@ -1791,7 +1791,7 @@
           <a:p>
             <a:fld id="{5BCAD085-E8A6-8845-BD4E-CB4CCA059FC4}" type="datetimeFigureOut">
               <a:rPr lang="en-US" smtClean="0"/>
-              <a:t>3/23/26</a:t>
+              <a:t>1/27/13</a:t>
             </a:fld>
             <a:endParaRPr lang="en-US"/>
           </a:p>
@@ -1885,9 +1885,10 @@
           <a:lstStyle/>
           <a:p>
             <a:r>
-              <a:rPr lang="en-US"/>
+              <a:rPr lang="en-US" smtClean="0"/>
               <a:t>Click to edit Master title style</a:t>
             </a:r>
+            <a:endParaRPr lang="en-US"/>
           </a:p>
         </p:txBody>
       </p:sp>
@@ -1908,7 +1909,7 @@
           <a:p>
             <a:fld id="{5BCAD085-E8A6-8845-BD4E-CB4CCA059FC4}" type="datetimeFigureOut">
               <a:rPr lang="en-US" smtClean="0"/>
-              <a:t>3/23/26</a:t>
+              <a:t>1/27/13</a:t>
             </a:fld>
             <a:endParaRPr lang="en-US"/>
           </a:p>
@@ -2003,7 +2004,7 @@
           <a:p>
             <a:fld id="{5BCAD085-E8A6-8845-BD4E-CB4CCA059FC4}" type="datetimeFigureOut">
               <a:rPr lang="en-US" smtClean="0"/>
-              <a:t>3/23/26</a:t>
+              <a:t>1/27/13</a:t>
             </a:fld>
             <a:endParaRPr lang="en-US"/>
           </a:p>
@@ -2106,9 +2107,10 @@
           </a:lstStyle>
           <a:p>
             <a:r>
-              <a:rPr lang="en-US"/>
+              <a:rPr lang="en-US" smtClean="0"/>
               <a:t>Click to edit Master title style</a:t>
             </a:r>
+            <a:endParaRPr lang="en-US"/>
           </a:p>
         </p:txBody>
       </p:sp>
@@ -2162,37 +2164,38 @@
           <a:p>
             <a:pPr lvl="0"/>
             <a:r>
-              <a:rPr lang="en-US"/>
+              <a:rPr lang="en-US" smtClean="0"/>
               <a:t>Click to edit Master text styles</a:t>
             </a:r>
           </a:p>
           <a:p>
             <a:pPr lvl="1"/>
             <a:r>
-              <a:rPr lang="en-US"/>
+              <a:rPr lang="en-US" smtClean="0"/>
               <a:t>Second level</a:t>
             </a:r>
           </a:p>
           <a:p>
             <a:pPr lvl="2"/>
             <a:r>
-              <a:rPr lang="en-US"/>
+              <a:rPr lang="en-US" smtClean="0"/>
               <a:t>Third level</a:t>
             </a:r>
           </a:p>
           <a:p>
             <a:pPr lvl="3"/>
             <a:r>
-              <a:rPr lang="en-US"/>
+              <a:rPr lang="en-US" smtClean="0"/>
               <a:t>Fourth level</a:t>
             </a:r>
           </a:p>
           <a:p>
             <a:pPr lvl="4"/>
             <a:r>
-              <a:rPr lang="en-US"/>
+              <a:rPr lang="en-US" smtClean="0"/>
               <a:t>Fifth level</a:t>
             </a:r>
+            <a:endParaRPr lang="en-US"/>
           </a:p>
         </p:txBody>
       </p:sp>
@@ -2255,7 +2258,7 @@
           <a:p>
             <a:pPr lvl="0"/>
             <a:r>
-              <a:rPr lang="en-US"/>
+              <a:rPr lang="en-US" smtClean="0"/>
               <a:t>Click to edit Master text styles</a:t>
             </a:r>
           </a:p>
@@ -2278,7 +2281,7 @@
           <a:p>
             <a:fld id="{5BCAD085-E8A6-8845-BD4E-CB4CCA059FC4}" type="datetimeFigureOut">
               <a:rPr lang="en-US" smtClean="0"/>
-              <a:t>3/23/26</a:t>
+              <a:t>1/27/13</a:t>
             </a:fld>
             <a:endParaRPr lang="en-US"/>
           </a:p>
@@ -2381,9 +2384,10 @@
           </a:lstStyle>
           <a:p>
             <a:r>
-              <a:rPr lang="en-US"/>
+              <a:rPr lang="en-US" smtClean="0"/>
               <a:t>Click to edit Master title style</a:t>
             </a:r>
+            <a:endParaRPr lang="en-US"/>
           </a:p>
         </p:txBody>
       </p:sp>
@@ -2507,7 +2511,7 @@
           <a:p>
             <a:pPr lvl="0"/>
             <a:r>
-              <a:rPr lang="en-US"/>
+              <a:rPr lang="en-US" smtClean="0"/>
               <a:t>Click to edit Master text styles</a:t>
             </a:r>
           </a:p>
@@ -2530,7 +2534,7 @@
           <a:p>
             <a:fld id="{5BCAD085-E8A6-8845-BD4E-CB4CCA059FC4}" type="datetimeFigureOut">
               <a:rPr lang="en-US" smtClean="0"/>
-              <a:t>3/23/26</a:t>
+              <a:t>1/27/13</a:t>
             </a:fld>
             <a:endParaRPr lang="en-US"/>
           </a:p>
@@ -2639,9 +2643,10 @@
           <a:lstStyle/>
           <a:p>
             <a:r>
-              <a:rPr lang="en-US"/>
+              <a:rPr lang="en-US" smtClean="0"/>
               <a:t>Click to edit Master title style</a:t>
             </a:r>
+            <a:endParaRPr lang="en-US"/>
           </a:p>
         </p:txBody>
       </p:sp>
@@ -2672,37 +2677,38 @@
           <a:p>
             <a:pPr lvl="0"/>
             <a:r>
-              <a:rPr lang="en-US"/>
+              <a:rPr lang="en-US" smtClean="0"/>
               <a:t>Click to edit Master text styles</a:t>
             </a:r>
           </a:p>
           <a:p>
             <a:pPr lvl="1"/>
             <a:r>
-              <a:rPr lang="en-US"/>
+              <a:rPr lang="en-US" smtClean="0"/>
               <a:t>Second level</a:t>
             </a:r>
           </a:p>
           <a:p>
             <a:pPr lvl="2"/>
             <a:r>
-              <a:rPr lang="en-US"/>
+              <a:rPr lang="en-US" smtClean="0"/>
               <a:t>Third level</a:t>
             </a:r>
           </a:p>
           <a:p>
             <a:pPr lvl="3"/>
             <a:r>
-              <a:rPr lang="en-US"/>
+              <a:rPr lang="en-US" smtClean="0"/>
               <a:t>Fourth level</a:t>
             </a:r>
           </a:p>
           <a:p>
             <a:pPr lvl="4"/>
             <a:r>
-              <a:rPr lang="en-US"/>
+              <a:rPr lang="en-US" smtClean="0"/>
               <a:t>Fifth level</a:t>
             </a:r>
+            <a:endParaRPr lang="en-US"/>
           </a:p>
         </p:txBody>
       </p:sp>
@@ -2741,7 +2747,7 @@
           <a:p>
             <a:fld id="{5BCAD085-E8A6-8845-BD4E-CB4CCA059FC4}" type="datetimeFigureOut">
               <a:rPr lang="en-US" smtClean="0"/>
-              <a:t>3/23/26</a:t>
+              <a:t>1/27/13</a:t>
             </a:fld>
             <a:endParaRPr lang="en-US"/>
           </a:p>
@@ -3100,7 +3106,7 @@
 </file>
 
 <file path=ppt/slides/slide1.xml><?xml version="1.0" encoding="utf-8"?>
-<p:sld xmlns:a="http://schemas.openxmlformats.org/drawingml/2006/main" xmlns:r="http://schemas.openxmlformats.org/officeDocument/2006/relationships" xmlns:p="http://schemas.openxmlformats.org/presentationml/2006/main">
+<p:sld xmlns:a="http://schemas.openxmlformats.org/drawingml/2006/main" xmlns:p="http://schemas.openxmlformats.org/presentationml/2006/main" xmlns:r="http://schemas.openxmlformats.org/officeDocument/2006/relationships">
   <p:cSld>
     <p:spTree>
       <p:nvGrpSpPr>
@@ -3108,14 +3114,7 @@
         <p:cNvGrpSpPr/>
         <p:nvPr/>
       </p:nvGrpSpPr>
-      <p:grpSpPr>
-        <a:xfrm>
-          <a:off x="0" y="0"/>
-          <a:ext cx="0" cy="0"/>
-          <a:chOff x="0" y="0"/>
-          <a:chExt cx="0" cy="0"/>
-        </a:xfrm>
-      </p:grpSpPr>
+      <p:grpSpPr/>
       <p:sp>
         <p:nvSpPr>
           <p:cNvPr id="2" name="Rectangle 1"/>
@@ -3156,7 +3155,6 @@
           <a:lstStyle/>
           <a:p>
             <a:pPr algn="ctr"/>
-            <a:endParaRPr/>
           </a:p>
         </p:txBody>
       </p:sp>
@@ -3200,7 +3198,6 @@
           <a:lstStyle/>
           <a:p>
             <a:pPr algn="ctr"/>
-            <a:endParaRPr/>
           </a:p>
         </p:txBody>
       </p:sp>
@@ -3244,7 +3241,6 @@
           <a:lstStyle/>
           <a:p>
             <a:pPr algn="ctr"/>
-            <a:endParaRPr/>
           </a:p>
         </p:txBody>
       </p:sp>
@@ -3365,7 +3361,7 @@
 </file>
 
 <file path=ppt/slides/slide10.xml><?xml version="1.0" encoding="utf-8"?>
-<p:sld xmlns:a="http://schemas.openxmlformats.org/drawingml/2006/main" xmlns:r="http://schemas.openxmlformats.org/officeDocument/2006/relationships" xmlns:p="http://schemas.openxmlformats.org/presentationml/2006/main">
+<p:sld xmlns:a="http://schemas.openxmlformats.org/drawingml/2006/main" xmlns:p="http://schemas.openxmlformats.org/presentationml/2006/main" xmlns:r="http://schemas.openxmlformats.org/officeDocument/2006/relationships">
   <p:cSld>
     <p:spTree>
       <p:nvGrpSpPr>
@@ -3373,14 +3369,7 @@
         <p:cNvGrpSpPr/>
         <p:nvPr/>
       </p:nvGrpSpPr>
-      <p:grpSpPr>
-        <a:xfrm>
-          <a:off x="0" y="0"/>
-          <a:ext cx="0" cy="0"/>
-          <a:chOff x="0" y="0"/>
-          <a:chExt cx="0" cy="0"/>
-        </a:xfrm>
-      </p:grpSpPr>
+      <p:grpSpPr/>
       <p:sp>
         <p:nvSpPr>
           <p:cNvPr id="2" name="Rectangle 1"/>
@@ -3421,7 +3410,6 @@
           <a:lstStyle/>
           <a:p>
             <a:pPr algn="ctr"/>
-            <a:endParaRPr/>
           </a:p>
         </p:txBody>
       </p:sp>
@@ -3501,7 +3489,6 @@
           <a:lstStyle/>
           <a:p>
             <a:pPr algn="ctr"/>
-            <a:endParaRPr/>
           </a:p>
         </p:txBody>
       </p:sp>
@@ -3545,7 +3532,6 @@
           <a:lstStyle/>
           <a:p>
             <a:pPr algn="ctr"/>
-            <a:endParaRPr/>
           </a:p>
         </p:txBody>
       </p:sp>
@@ -3565,8 +3551,8 @@
         </p:blipFill>
         <p:spPr>
           <a:xfrm>
-            <a:off x="1581751" y="1239756"/>
-            <a:ext cx="9344265" cy="4012727"/>
+            <a:off x="548640" y="1005840"/>
+            <a:ext cx="10972800" cy="4712072"/>
           </a:xfrm>
           <a:prstGeom prst="rect">
             <a:avLst/>
@@ -3618,7 +3604,7 @@
 </file>
 
 <file path=ppt/slides/slide11.xml><?xml version="1.0" encoding="utf-8"?>
-<p:sld xmlns:a="http://schemas.openxmlformats.org/drawingml/2006/main" xmlns:r="http://schemas.openxmlformats.org/officeDocument/2006/relationships" xmlns:p="http://schemas.openxmlformats.org/presentationml/2006/main">
+<p:sld xmlns:a="http://schemas.openxmlformats.org/drawingml/2006/main" xmlns:p="http://schemas.openxmlformats.org/presentationml/2006/main" xmlns:r="http://schemas.openxmlformats.org/officeDocument/2006/relationships">
   <p:cSld>
     <p:spTree>
       <p:nvGrpSpPr>
@@ -3626,14 +3612,7 @@
         <p:cNvGrpSpPr/>
         <p:nvPr/>
       </p:nvGrpSpPr>
-      <p:grpSpPr>
-        <a:xfrm>
-          <a:off x="0" y="0"/>
-          <a:ext cx="0" cy="0"/>
-          <a:chOff x="0" y="0"/>
-          <a:chExt cx="0" cy="0"/>
-        </a:xfrm>
-      </p:grpSpPr>
+      <p:grpSpPr/>
       <p:sp>
         <p:nvSpPr>
           <p:cNvPr id="2" name="Rectangle 1"/>
@@ -3674,7 +3653,6 @@
           <a:lstStyle/>
           <a:p>
             <a:pPr algn="ctr"/>
-            <a:endParaRPr/>
           </a:p>
         </p:txBody>
       </p:sp>
@@ -3790,7 +3768,6 @@
           <a:lstStyle/>
           <a:p>
             <a:pPr algn="ctr"/>
-            <a:endParaRPr/>
           </a:p>
         </p:txBody>
       </p:sp>
@@ -3803,7 +3780,7 @@
 </file>
 
 <file path=ppt/slides/slide12.xml><?xml version="1.0" encoding="utf-8"?>
-<p:sld xmlns:a="http://schemas.openxmlformats.org/drawingml/2006/main" xmlns:r="http://schemas.openxmlformats.org/officeDocument/2006/relationships" xmlns:p="http://schemas.openxmlformats.org/presentationml/2006/main">
+<p:sld xmlns:a="http://schemas.openxmlformats.org/drawingml/2006/main" xmlns:p="http://schemas.openxmlformats.org/presentationml/2006/main" xmlns:r="http://schemas.openxmlformats.org/officeDocument/2006/relationships">
   <p:cSld>
     <p:spTree>
       <p:nvGrpSpPr>
@@ -3811,14 +3788,7 @@
         <p:cNvGrpSpPr/>
         <p:nvPr/>
       </p:nvGrpSpPr>
-      <p:grpSpPr>
-        <a:xfrm>
-          <a:off x="0" y="0"/>
-          <a:ext cx="0" cy="0"/>
-          <a:chOff x="0" y="0"/>
-          <a:chExt cx="0" cy="0"/>
-        </a:xfrm>
-      </p:grpSpPr>
+      <p:grpSpPr/>
       <p:sp>
         <p:nvSpPr>
           <p:cNvPr id="2" name="Rectangle 1"/>
@@ -3859,7 +3829,6 @@
           <a:lstStyle/>
           <a:p>
             <a:pPr algn="ctr"/>
-            <a:endParaRPr/>
           </a:p>
         </p:txBody>
       </p:sp>
@@ -3939,7 +3908,6 @@
           <a:lstStyle/>
           <a:p>
             <a:pPr algn="ctr"/>
-            <a:endParaRPr/>
           </a:p>
         </p:txBody>
       </p:sp>
@@ -3983,7 +3951,6 @@
           <a:lstStyle/>
           <a:p>
             <a:pPr algn="ctr"/>
-            <a:endParaRPr/>
           </a:p>
         </p:txBody>
       </p:sp>
@@ -4003,8 +3970,8 @@
         </p:blipFill>
         <p:spPr>
           <a:xfrm>
-            <a:off x="1201478" y="1529727"/>
-            <a:ext cx="9405561" cy="3798545"/>
+            <a:off x="548640" y="1005840"/>
+            <a:ext cx="10972800" cy="4431493"/>
           </a:xfrm>
           <a:prstGeom prst="rect">
             <a:avLst/>
@@ -4056,7 +4023,7 @@
 </file>
 
 <file path=ppt/slides/slide13.xml><?xml version="1.0" encoding="utf-8"?>
-<p:sld xmlns:a="http://schemas.openxmlformats.org/drawingml/2006/main" xmlns:r="http://schemas.openxmlformats.org/officeDocument/2006/relationships" xmlns:p="http://schemas.openxmlformats.org/presentationml/2006/main">
+<p:sld xmlns:a="http://schemas.openxmlformats.org/drawingml/2006/main" xmlns:p="http://schemas.openxmlformats.org/presentationml/2006/main" xmlns:r="http://schemas.openxmlformats.org/officeDocument/2006/relationships">
   <p:cSld>
     <p:spTree>
       <p:nvGrpSpPr>
@@ -4064,14 +4031,7 @@
         <p:cNvGrpSpPr/>
         <p:nvPr/>
       </p:nvGrpSpPr>
-      <p:grpSpPr>
-        <a:xfrm>
-          <a:off x="0" y="0"/>
-          <a:ext cx="0" cy="0"/>
-          <a:chOff x="0" y="0"/>
-          <a:chExt cx="0" cy="0"/>
-        </a:xfrm>
-      </p:grpSpPr>
+      <p:grpSpPr/>
       <p:sp>
         <p:nvSpPr>
           <p:cNvPr id="2" name="Rectangle 1"/>
@@ -4112,7 +4072,6 @@
           <a:lstStyle/>
           <a:p>
             <a:pPr algn="ctr"/>
-            <a:endParaRPr/>
           </a:p>
         </p:txBody>
       </p:sp>
@@ -4192,7 +4151,6 @@
           <a:lstStyle/>
           <a:p>
             <a:pPr algn="ctr"/>
-            <a:endParaRPr/>
           </a:p>
         </p:txBody>
       </p:sp>
@@ -4340,7 +4298,7 @@
 </file>
 
 <file path=ppt/slides/slide14.xml><?xml version="1.0" encoding="utf-8"?>
-<p:sld xmlns:a="http://schemas.openxmlformats.org/drawingml/2006/main" xmlns:r="http://schemas.openxmlformats.org/officeDocument/2006/relationships" xmlns:p="http://schemas.openxmlformats.org/presentationml/2006/main">
+<p:sld xmlns:a="http://schemas.openxmlformats.org/drawingml/2006/main" xmlns:p="http://schemas.openxmlformats.org/presentationml/2006/main" xmlns:r="http://schemas.openxmlformats.org/officeDocument/2006/relationships">
   <p:cSld>
     <p:spTree>
       <p:nvGrpSpPr>
@@ -4348,14 +4306,7 @@
         <p:cNvGrpSpPr/>
         <p:nvPr/>
       </p:nvGrpSpPr>
-      <p:grpSpPr>
-        <a:xfrm>
-          <a:off x="0" y="0"/>
-          <a:ext cx="0" cy="0"/>
-          <a:chOff x="0" y="0"/>
-          <a:chExt cx="0" cy="0"/>
-        </a:xfrm>
-      </p:grpSpPr>
+      <p:grpSpPr/>
       <p:sp>
         <p:nvSpPr>
           <p:cNvPr id="2" name="Rectangle 1"/>
@@ -4396,7 +4347,6 @@
           <a:lstStyle/>
           <a:p>
             <a:pPr algn="ctr"/>
-            <a:endParaRPr/>
           </a:p>
         </p:txBody>
       </p:sp>
@@ -4512,7 +4462,6 @@
           <a:lstStyle/>
           <a:p>
             <a:pPr algn="ctr"/>
-            <a:endParaRPr/>
           </a:p>
         </p:txBody>
       </p:sp>
@@ -4525,7 +4474,7 @@
 </file>
 
 <file path=ppt/slides/slide15.xml><?xml version="1.0" encoding="utf-8"?>
-<p:sld xmlns:a="http://schemas.openxmlformats.org/drawingml/2006/main" xmlns:r="http://schemas.openxmlformats.org/officeDocument/2006/relationships" xmlns:p="http://schemas.openxmlformats.org/presentationml/2006/main">
+<p:sld xmlns:a="http://schemas.openxmlformats.org/drawingml/2006/main" xmlns:p="http://schemas.openxmlformats.org/presentationml/2006/main" xmlns:r="http://schemas.openxmlformats.org/officeDocument/2006/relationships">
   <p:cSld>
     <p:spTree>
       <p:nvGrpSpPr>
@@ -4533,14 +4482,7 @@
         <p:cNvGrpSpPr/>
         <p:nvPr/>
       </p:nvGrpSpPr>
-      <p:grpSpPr>
-        <a:xfrm>
-          <a:off x="0" y="0"/>
-          <a:ext cx="0" cy="0"/>
-          <a:chOff x="0" y="0"/>
-          <a:chExt cx="0" cy="0"/>
-        </a:xfrm>
-      </p:grpSpPr>
+      <p:grpSpPr/>
       <p:sp>
         <p:nvSpPr>
           <p:cNvPr id="2" name="Rectangle 1"/>
@@ -4581,7 +4523,6 @@
           <a:lstStyle/>
           <a:p>
             <a:pPr algn="ctr"/>
-            <a:endParaRPr/>
           </a:p>
         </p:txBody>
       </p:sp>
@@ -4661,7 +4602,6 @@
           <a:lstStyle/>
           <a:p>
             <a:pPr algn="ctr"/>
-            <a:endParaRPr/>
           </a:p>
         </p:txBody>
       </p:sp>
@@ -4705,7 +4645,6 @@
           <a:lstStyle/>
           <a:p>
             <a:pPr algn="ctr"/>
-            <a:endParaRPr/>
           </a:p>
         </p:txBody>
       </p:sp>
@@ -4725,8 +4664,8 @@
         </p:blipFill>
         <p:spPr>
           <a:xfrm>
-            <a:off x="1371599" y="1005840"/>
-            <a:ext cx="8225347" cy="4296909"/>
+            <a:off x="548640" y="1005840"/>
+            <a:ext cx="10972800" cy="5732175"/>
           </a:xfrm>
           <a:prstGeom prst="rect">
             <a:avLst/>
@@ -4778,7 +4717,7 @@
 </file>
 
 <file path=ppt/slides/slide16.xml><?xml version="1.0" encoding="utf-8"?>
-<p:sld xmlns:a="http://schemas.openxmlformats.org/drawingml/2006/main" xmlns:r="http://schemas.openxmlformats.org/officeDocument/2006/relationships" xmlns:p="http://schemas.openxmlformats.org/presentationml/2006/main">
+<p:sld xmlns:a="http://schemas.openxmlformats.org/drawingml/2006/main" xmlns:p="http://schemas.openxmlformats.org/presentationml/2006/main" xmlns:r="http://schemas.openxmlformats.org/officeDocument/2006/relationships">
   <p:cSld>
     <p:spTree>
       <p:nvGrpSpPr>
@@ -4786,14 +4725,7 @@
         <p:cNvGrpSpPr/>
         <p:nvPr/>
       </p:nvGrpSpPr>
-      <p:grpSpPr>
-        <a:xfrm>
-          <a:off x="0" y="0"/>
-          <a:ext cx="0" cy="0"/>
-          <a:chOff x="0" y="0"/>
-          <a:chExt cx="0" cy="0"/>
-        </a:xfrm>
-      </p:grpSpPr>
+      <p:grpSpPr/>
       <p:sp>
         <p:nvSpPr>
           <p:cNvPr id="2" name="Rectangle 1"/>
@@ -4834,7 +4766,6 @@
           <a:lstStyle/>
           <a:p>
             <a:pPr algn="ctr"/>
-            <a:endParaRPr/>
           </a:p>
         </p:txBody>
       </p:sp>
@@ -4950,7 +4881,6 @@
           <a:lstStyle/>
           <a:p>
             <a:pPr algn="ctr"/>
-            <a:endParaRPr/>
           </a:p>
         </p:txBody>
       </p:sp>
@@ -4963,7 +4893,7 @@
 </file>
 
 <file path=ppt/slides/slide17.xml><?xml version="1.0" encoding="utf-8"?>
-<p:sld xmlns:a="http://schemas.openxmlformats.org/drawingml/2006/main" xmlns:r="http://schemas.openxmlformats.org/officeDocument/2006/relationships" xmlns:p="http://schemas.openxmlformats.org/presentationml/2006/main">
+<p:sld xmlns:a="http://schemas.openxmlformats.org/drawingml/2006/main" xmlns:p="http://schemas.openxmlformats.org/presentationml/2006/main" xmlns:r="http://schemas.openxmlformats.org/officeDocument/2006/relationships">
   <p:cSld>
     <p:spTree>
       <p:nvGrpSpPr>
@@ -4971,14 +4901,7 @@
         <p:cNvGrpSpPr/>
         <p:nvPr/>
       </p:nvGrpSpPr>
-      <p:grpSpPr>
-        <a:xfrm>
-          <a:off x="0" y="0"/>
-          <a:ext cx="0" cy="0"/>
-          <a:chOff x="0" y="0"/>
-          <a:chExt cx="0" cy="0"/>
-        </a:xfrm>
-      </p:grpSpPr>
+      <p:grpSpPr/>
       <p:sp>
         <p:nvSpPr>
           <p:cNvPr id="2" name="Rectangle 1"/>
@@ -5019,7 +4942,6 @@
           <a:lstStyle/>
           <a:p>
             <a:pPr algn="ctr"/>
-            <a:endParaRPr/>
           </a:p>
         </p:txBody>
       </p:sp>
@@ -5099,7 +5021,6 @@
           <a:lstStyle/>
           <a:p>
             <a:pPr algn="ctr"/>
-            <a:endParaRPr/>
           </a:p>
         </p:txBody>
       </p:sp>
@@ -5122,27 +5043,9 @@
                 <a:tableStyleId>{5C22544A-7EE6-4342-B048-85BDC9FD1C3A}</a:tableStyleId>
               </a:tblPr>
               <a:tblGrid>
-                <a:gridCol w="3505200">
-                  <a:extLst>
-                    <a:ext uri="{9D8B030D-6E8A-4147-A177-3AD203B41FA5}">
-                      <a16:colId xmlns:a16="http://schemas.microsoft.com/office/drawing/2014/main" val="20000"/>
-                    </a:ext>
-                  </a:extLst>
-                </a:gridCol>
-                <a:gridCol w="3505200">
-                  <a:extLst>
-                    <a:ext uri="{9D8B030D-6E8A-4147-A177-3AD203B41FA5}">
-                      <a16:colId xmlns:a16="http://schemas.microsoft.com/office/drawing/2014/main" val="20001"/>
-                    </a:ext>
-                  </a:extLst>
-                </a:gridCol>
-                <a:gridCol w="3505200">
-                  <a:extLst>
-                    <a:ext uri="{9D8B030D-6E8A-4147-A177-3AD203B41FA5}">
-                      <a16:colId xmlns:a16="http://schemas.microsoft.com/office/drawing/2014/main" val="20002"/>
-                    </a:ext>
-                  </a:extLst>
-                </a:gridCol>
+                <a:gridCol w="3505200"/>
+                <a:gridCol w="3505200"/>
+                <a:gridCol w="3505200"/>
               </a:tblGrid>
               <a:tr h="548640">
                 <a:tc>
@@ -5151,7 +5054,7 @@
                     <a:lstStyle/>
                     <a:p>
                       <a:pPr>
-                        <a:defRPr sz="1400" b="1">
+                        <a:defRPr b="1" sz="1400">
                           <a:solidFill>
                             <a:srgbClr val="000000"/>
                           </a:solidFill>
@@ -5175,7 +5078,7 @@
                     <a:lstStyle/>
                     <a:p>
                       <a:pPr>
-                        <a:defRPr sz="1400" b="1">
+                        <a:defRPr b="1" sz="1400">
                           <a:solidFill>
                             <a:srgbClr val="000000"/>
                           </a:solidFill>
@@ -5199,7 +5102,7 @@
                     <a:lstStyle/>
                     <a:p>
                       <a:pPr>
-                        <a:defRPr sz="1400" b="1">
+                        <a:defRPr b="1" sz="1400">
                           <a:solidFill>
                             <a:srgbClr val="000000"/>
                           </a:solidFill>
@@ -5217,11 +5120,6 @@
                     </a:solidFill>
                   </a:tcPr>
                 </a:tc>
-                <a:extLst>
-                  <a:ext uri="{0D108BD9-81ED-4DB2-BD59-A6C34878D82A}">
-                    <a16:rowId xmlns:a16="http://schemas.microsoft.com/office/drawing/2014/main" val="10000"/>
-                  </a:ext>
-                </a:extLst>
               </a:tr>
               <a:tr h="548640">
                 <a:tc>
@@ -5296,11 +5194,6 @@
                     </a:solidFill>
                   </a:tcPr>
                 </a:tc>
-                <a:extLst>
-                  <a:ext uri="{0D108BD9-81ED-4DB2-BD59-A6C34878D82A}">
-                    <a16:rowId xmlns:a16="http://schemas.microsoft.com/office/drawing/2014/main" val="10001"/>
-                  </a:ext>
-                </a:extLst>
               </a:tr>
               <a:tr h="548640">
                 <a:tc>
@@ -5375,11 +5268,6 @@
                     </a:solidFill>
                   </a:tcPr>
                 </a:tc>
-                <a:extLst>
-                  <a:ext uri="{0D108BD9-81ED-4DB2-BD59-A6C34878D82A}">
-                    <a16:rowId xmlns:a16="http://schemas.microsoft.com/office/drawing/2014/main" val="10002"/>
-                  </a:ext>
-                </a:extLst>
               </a:tr>
               <a:tr h="548640">
                 <a:tc>
@@ -5454,11 +5342,6 @@
                     </a:solidFill>
                   </a:tcPr>
                 </a:tc>
-                <a:extLst>
-                  <a:ext uri="{0D108BD9-81ED-4DB2-BD59-A6C34878D82A}">
-                    <a16:rowId xmlns:a16="http://schemas.microsoft.com/office/drawing/2014/main" val="10003"/>
-                  </a:ext>
-                </a:extLst>
               </a:tr>
             </a:tbl>
           </a:graphicData>
@@ -5473,7 +5356,7 @@
 </file>
 
 <file path=ppt/slides/slide18.xml><?xml version="1.0" encoding="utf-8"?>
-<p:sld xmlns:a="http://schemas.openxmlformats.org/drawingml/2006/main" xmlns:r="http://schemas.openxmlformats.org/officeDocument/2006/relationships" xmlns:p="http://schemas.openxmlformats.org/presentationml/2006/main">
+<p:sld xmlns:a="http://schemas.openxmlformats.org/drawingml/2006/main" xmlns:p="http://schemas.openxmlformats.org/presentationml/2006/main" xmlns:r="http://schemas.openxmlformats.org/officeDocument/2006/relationships">
   <p:cSld>
     <p:spTree>
       <p:nvGrpSpPr>
@@ -5481,14 +5364,7 @@
         <p:cNvGrpSpPr/>
         <p:nvPr/>
       </p:nvGrpSpPr>
-      <p:grpSpPr>
-        <a:xfrm>
-          <a:off x="0" y="0"/>
-          <a:ext cx="0" cy="0"/>
-          <a:chOff x="0" y="0"/>
-          <a:chExt cx="0" cy="0"/>
-        </a:xfrm>
-      </p:grpSpPr>
+      <p:grpSpPr/>
       <p:sp>
         <p:nvSpPr>
           <p:cNvPr id="2" name="Rectangle 1"/>
@@ -5529,7 +5405,6 @@
           <a:lstStyle/>
           <a:p>
             <a:pPr algn="ctr"/>
-            <a:endParaRPr/>
           </a:p>
         </p:txBody>
       </p:sp>
@@ -5609,7 +5484,6 @@
           <a:lstStyle/>
           <a:p>
             <a:pPr algn="ctr"/>
-            <a:endParaRPr/>
           </a:p>
         </p:txBody>
       </p:sp>
@@ -5653,7 +5527,6 @@
           <a:lstStyle/>
           <a:p>
             <a:pPr algn="ctr"/>
-            <a:endParaRPr/>
           </a:p>
         </p:txBody>
       </p:sp>
@@ -5726,7 +5599,7 @@
 </file>
 
 <file path=ppt/slides/slide19.xml><?xml version="1.0" encoding="utf-8"?>
-<p:sld xmlns:a="http://schemas.openxmlformats.org/drawingml/2006/main" xmlns:r="http://schemas.openxmlformats.org/officeDocument/2006/relationships" xmlns:p="http://schemas.openxmlformats.org/presentationml/2006/main">
+<p:sld xmlns:a="http://schemas.openxmlformats.org/drawingml/2006/main" xmlns:p="http://schemas.openxmlformats.org/presentationml/2006/main" xmlns:r="http://schemas.openxmlformats.org/officeDocument/2006/relationships">
   <p:cSld>
     <p:spTree>
       <p:nvGrpSpPr>
@@ -5734,14 +5607,7 @@
         <p:cNvGrpSpPr/>
         <p:nvPr/>
       </p:nvGrpSpPr>
-      <p:grpSpPr>
-        <a:xfrm>
-          <a:off x="0" y="0"/>
-          <a:ext cx="0" cy="0"/>
-          <a:chOff x="0" y="0"/>
-          <a:chExt cx="0" cy="0"/>
-        </a:xfrm>
-      </p:grpSpPr>
+      <p:grpSpPr/>
       <p:sp>
         <p:nvSpPr>
           <p:cNvPr id="2" name="Rectangle 1"/>
@@ -5782,7 +5648,6 @@
           <a:lstStyle/>
           <a:p>
             <a:pPr algn="ctr"/>
-            <a:endParaRPr/>
           </a:p>
         </p:txBody>
       </p:sp>
@@ -5862,7 +5727,6 @@
           <a:lstStyle/>
           <a:p>
             <a:pPr algn="ctr"/>
-            <a:endParaRPr/>
           </a:p>
         </p:txBody>
       </p:sp>
@@ -5906,7 +5770,6 @@
           <a:lstStyle/>
           <a:p>
             <a:pPr algn="ctr"/>
-            <a:endParaRPr/>
           </a:p>
         </p:txBody>
       </p:sp>
@@ -5926,8 +5789,8 @@
         </p:blipFill>
         <p:spPr>
           <a:xfrm>
-            <a:off x="1263147" y="1190950"/>
-            <a:ext cx="9380447" cy="4476100"/>
+            <a:off x="548640" y="1005840"/>
+            <a:ext cx="10972800" cy="5235929"/>
           </a:xfrm>
           <a:prstGeom prst="rect">
             <a:avLst/>
@@ -5979,7 +5842,7 @@
 </file>
 
 <file path=ppt/slides/slide2.xml><?xml version="1.0" encoding="utf-8"?>
-<p:sld xmlns:a="http://schemas.openxmlformats.org/drawingml/2006/main" xmlns:r="http://schemas.openxmlformats.org/officeDocument/2006/relationships" xmlns:p="http://schemas.openxmlformats.org/presentationml/2006/main">
+<p:sld xmlns:a="http://schemas.openxmlformats.org/drawingml/2006/main" xmlns:p="http://schemas.openxmlformats.org/presentationml/2006/main" xmlns:r="http://schemas.openxmlformats.org/officeDocument/2006/relationships">
   <p:cSld>
     <p:spTree>
       <p:nvGrpSpPr>
@@ -5987,14 +5850,7 @@
         <p:cNvGrpSpPr/>
         <p:nvPr/>
       </p:nvGrpSpPr>
-      <p:grpSpPr>
-        <a:xfrm>
-          <a:off x="0" y="0"/>
-          <a:ext cx="0" cy="0"/>
-          <a:chOff x="0" y="0"/>
-          <a:chExt cx="0" cy="0"/>
-        </a:xfrm>
-      </p:grpSpPr>
+      <p:grpSpPr/>
       <p:sp>
         <p:nvSpPr>
           <p:cNvPr id="2" name="Rectangle 1"/>
@@ -6035,7 +5891,6 @@
           <a:lstStyle/>
           <a:p>
             <a:pPr algn="ctr"/>
-            <a:endParaRPr/>
           </a:p>
         </p:txBody>
       </p:sp>
@@ -6151,7 +6006,6 @@
           <a:lstStyle/>
           <a:p>
             <a:pPr algn="ctr"/>
-            <a:endParaRPr/>
           </a:p>
         </p:txBody>
       </p:sp>
@@ -6164,7 +6018,7 @@
 </file>
 
 <file path=ppt/slides/slide20.xml><?xml version="1.0" encoding="utf-8"?>
-<p:sld xmlns:a="http://schemas.openxmlformats.org/drawingml/2006/main" xmlns:r="http://schemas.openxmlformats.org/officeDocument/2006/relationships" xmlns:p="http://schemas.openxmlformats.org/presentationml/2006/main">
+<p:sld xmlns:a="http://schemas.openxmlformats.org/drawingml/2006/main" xmlns:p="http://schemas.openxmlformats.org/presentationml/2006/main" xmlns:r="http://schemas.openxmlformats.org/officeDocument/2006/relationships">
   <p:cSld>
     <p:spTree>
       <p:nvGrpSpPr>
@@ -6172,14 +6026,7 @@
         <p:cNvGrpSpPr/>
         <p:nvPr/>
       </p:nvGrpSpPr>
-      <p:grpSpPr>
-        <a:xfrm>
-          <a:off x="0" y="0"/>
-          <a:ext cx="0" cy="0"/>
-          <a:chOff x="0" y="0"/>
-          <a:chExt cx="0" cy="0"/>
-        </a:xfrm>
-      </p:grpSpPr>
+      <p:grpSpPr/>
       <p:sp>
         <p:nvSpPr>
           <p:cNvPr id="2" name="Rectangle 1"/>
@@ -6220,7 +6067,6 @@
           <a:lstStyle/>
           <a:p>
             <a:pPr algn="ctr"/>
-            <a:endParaRPr/>
           </a:p>
         </p:txBody>
       </p:sp>
@@ -6336,7 +6182,6 @@
           <a:lstStyle/>
           <a:p>
             <a:pPr algn="ctr"/>
-            <a:endParaRPr/>
           </a:p>
         </p:txBody>
       </p:sp>
@@ -6349,7 +6194,7 @@
 </file>
 
 <file path=ppt/slides/slide21.xml><?xml version="1.0" encoding="utf-8"?>
-<p:sld xmlns:a="http://schemas.openxmlformats.org/drawingml/2006/main" xmlns:r="http://schemas.openxmlformats.org/officeDocument/2006/relationships" xmlns:p="http://schemas.openxmlformats.org/presentationml/2006/main">
+<p:sld xmlns:a="http://schemas.openxmlformats.org/drawingml/2006/main" xmlns:p="http://schemas.openxmlformats.org/presentationml/2006/main" xmlns:r="http://schemas.openxmlformats.org/officeDocument/2006/relationships">
   <p:cSld>
     <p:spTree>
       <p:nvGrpSpPr>
@@ -6357,14 +6202,7 @@
         <p:cNvGrpSpPr/>
         <p:nvPr/>
       </p:nvGrpSpPr>
-      <p:grpSpPr>
-        <a:xfrm>
-          <a:off x="0" y="0"/>
-          <a:ext cx="0" cy="0"/>
-          <a:chOff x="0" y="0"/>
-          <a:chExt cx="0" cy="0"/>
-        </a:xfrm>
-      </p:grpSpPr>
+      <p:grpSpPr/>
       <p:sp>
         <p:nvSpPr>
           <p:cNvPr id="2" name="Rectangle 1"/>
@@ -6405,7 +6243,6 @@
           <a:lstStyle/>
           <a:p>
             <a:pPr algn="ctr"/>
-            <a:endParaRPr/>
           </a:p>
         </p:txBody>
       </p:sp>
@@ -6485,7 +6322,6 @@
           <a:lstStyle/>
           <a:p>
             <a:pPr algn="ctr"/>
-            <a:endParaRPr/>
           </a:p>
         </p:txBody>
       </p:sp>
@@ -6617,7 +6453,7 @@
 </file>
 
 <file path=ppt/slides/slide22.xml><?xml version="1.0" encoding="utf-8"?>
-<p:sld xmlns:a="http://schemas.openxmlformats.org/drawingml/2006/main" xmlns:r="http://schemas.openxmlformats.org/officeDocument/2006/relationships" xmlns:p="http://schemas.openxmlformats.org/presentationml/2006/main">
+<p:sld xmlns:a="http://schemas.openxmlformats.org/drawingml/2006/main" xmlns:p="http://schemas.openxmlformats.org/presentationml/2006/main" xmlns:r="http://schemas.openxmlformats.org/officeDocument/2006/relationships">
   <p:cSld>
     <p:spTree>
       <p:nvGrpSpPr>
@@ -6625,14 +6461,7 @@
         <p:cNvGrpSpPr/>
         <p:nvPr/>
       </p:nvGrpSpPr>
-      <p:grpSpPr>
-        <a:xfrm>
-          <a:off x="0" y="0"/>
-          <a:ext cx="0" cy="0"/>
-          <a:chOff x="0" y="0"/>
-          <a:chExt cx="0" cy="0"/>
-        </a:xfrm>
-      </p:grpSpPr>
+      <p:grpSpPr/>
       <p:sp>
         <p:nvSpPr>
           <p:cNvPr id="2" name="Rectangle 1"/>
@@ -6673,7 +6502,6 @@
           <a:lstStyle/>
           <a:p>
             <a:pPr algn="ctr"/>
-            <a:endParaRPr/>
           </a:p>
         </p:txBody>
       </p:sp>
@@ -6753,7 +6581,6 @@
           <a:lstStyle/>
           <a:p>
             <a:pPr algn="ctr"/>
-            <a:endParaRPr/>
           </a:p>
         </p:txBody>
       </p:sp>
@@ -6885,7 +6712,7 @@
 </file>
 
 <file path=ppt/slides/slide23.xml><?xml version="1.0" encoding="utf-8"?>
-<p:sld xmlns:a="http://schemas.openxmlformats.org/drawingml/2006/main" xmlns:r="http://schemas.openxmlformats.org/officeDocument/2006/relationships" xmlns:p="http://schemas.openxmlformats.org/presentationml/2006/main">
+<p:sld xmlns:a="http://schemas.openxmlformats.org/drawingml/2006/main" xmlns:p="http://schemas.openxmlformats.org/presentationml/2006/main" xmlns:r="http://schemas.openxmlformats.org/officeDocument/2006/relationships">
   <p:cSld>
     <p:spTree>
       <p:nvGrpSpPr>
@@ -6893,14 +6720,7 @@
         <p:cNvGrpSpPr/>
         <p:nvPr/>
       </p:nvGrpSpPr>
-      <p:grpSpPr>
-        <a:xfrm>
-          <a:off x="0" y="0"/>
-          <a:ext cx="0" cy="0"/>
-          <a:chOff x="0" y="0"/>
-          <a:chExt cx="0" cy="0"/>
-        </a:xfrm>
-      </p:grpSpPr>
+      <p:grpSpPr/>
       <p:sp>
         <p:nvSpPr>
           <p:cNvPr id="2" name="Rectangle 1"/>
@@ -6941,7 +6761,6 @@
           <a:lstStyle/>
           <a:p>
             <a:pPr algn="ctr"/>
-            <a:endParaRPr/>
           </a:p>
         </p:txBody>
       </p:sp>
@@ -7021,7 +6840,6 @@
           <a:lstStyle/>
           <a:p>
             <a:pPr algn="ctr"/>
-            <a:endParaRPr/>
           </a:p>
         </p:txBody>
       </p:sp>
@@ -7153,7 +6971,7 @@
 </file>
 
 <file path=ppt/slides/slide24.xml><?xml version="1.0" encoding="utf-8"?>
-<p:sld xmlns:a="http://schemas.openxmlformats.org/drawingml/2006/main" xmlns:r="http://schemas.openxmlformats.org/officeDocument/2006/relationships" xmlns:p="http://schemas.openxmlformats.org/presentationml/2006/main">
+<p:sld xmlns:a="http://schemas.openxmlformats.org/drawingml/2006/main" xmlns:p="http://schemas.openxmlformats.org/presentationml/2006/main" xmlns:r="http://schemas.openxmlformats.org/officeDocument/2006/relationships">
   <p:cSld>
     <p:spTree>
       <p:nvGrpSpPr>
@@ -7161,14 +6979,7 @@
         <p:cNvGrpSpPr/>
         <p:nvPr/>
       </p:nvGrpSpPr>
-      <p:grpSpPr>
-        <a:xfrm>
-          <a:off x="0" y="0"/>
-          <a:ext cx="0" cy="0"/>
-          <a:chOff x="0" y="0"/>
-          <a:chExt cx="0" cy="0"/>
-        </a:xfrm>
-      </p:grpSpPr>
+      <p:grpSpPr/>
       <p:sp>
         <p:nvSpPr>
           <p:cNvPr id="2" name="Rectangle 1"/>
@@ -7209,7 +7020,6 @@
           <a:lstStyle/>
           <a:p>
             <a:pPr algn="ctr"/>
-            <a:endParaRPr/>
           </a:p>
         </p:txBody>
       </p:sp>
@@ -7325,7 +7135,6 @@
           <a:lstStyle/>
           <a:p>
             <a:pPr algn="ctr"/>
-            <a:endParaRPr/>
           </a:p>
         </p:txBody>
       </p:sp>
@@ -7338,7 +7147,7 @@
 </file>
 
 <file path=ppt/slides/slide25.xml><?xml version="1.0" encoding="utf-8"?>
-<p:sld xmlns:a="http://schemas.openxmlformats.org/drawingml/2006/main" xmlns:r="http://schemas.openxmlformats.org/officeDocument/2006/relationships" xmlns:p="http://schemas.openxmlformats.org/presentationml/2006/main">
+<p:sld xmlns:a="http://schemas.openxmlformats.org/drawingml/2006/main" xmlns:p="http://schemas.openxmlformats.org/presentationml/2006/main" xmlns:r="http://schemas.openxmlformats.org/officeDocument/2006/relationships">
   <p:cSld>
     <p:spTree>
       <p:nvGrpSpPr>
@@ -7346,14 +7155,7 @@
         <p:cNvGrpSpPr/>
         <p:nvPr/>
       </p:nvGrpSpPr>
-      <p:grpSpPr>
-        <a:xfrm>
-          <a:off x="0" y="0"/>
-          <a:ext cx="0" cy="0"/>
-          <a:chOff x="0" y="0"/>
-          <a:chExt cx="0" cy="0"/>
-        </a:xfrm>
-      </p:grpSpPr>
+      <p:grpSpPr/>
       <p:sp>
         <p:nvSpPr>
           <p:cNvPr id="2" name="Rectangle 1"/>
@@ -7394,7 +7196,6 @@
           <a:lstStyle/>
           <a:p>
             <a:pPr algn="ctr"/>
-            <a:endParaRPr/>
           </a:p>
         </p:txBody>
       </p:sp>
@@ -7474,7 +7275,6 @@
           <a:lstStyle/>
           <a:p>
             <a:pPr algn="ctr"/>
-            <a:endParaRPr/>
           </a:p>
         </p:txBody>
       </p:sp>
@@ -7590,7 +7390,7 @@
 </file>
 
 <file path=ppt/slides/slide26.xml><?xml version="1.0" encoding="utf-8"?>
-<p:sld xmlns:a="http://schemas.openxmlformats.org/drawingml/2006/main" xmlns:r="http://schemas.openxmlformats.org/officeDocument/2006/relationships" xmlns:p="http://schemas.openxmlformats.org/presentationml/2006/main">
+<p:sld xmlns:a="http://schemas.openxmlformats.org/drawingml/2006/main" xmlns:p="http://schemas.openxmlformats.org/presentationml/2006/main" xmlns:r="http://schemas.openxmlformats.org/officeDocument/2006/relationships">
   <p:cSld>
     <p:spTree>
       <p:nvGrpSpPr>
@@ -7598,14 +7398,7 @@
         <p:cNvGrpSpPr/>
         <p:nvPr/>
       </p:nvGrpSpPr>
-      <p:grpSpPr>
-        <a:xfrm>
-          <a:off x="0" y="0"/>
-          <a:ext cx="0" cy="0"/>
-          <a:chOff x="0" y="0"/>
-          <a:chExt cx="0" cy="0"/>
-        </a:xfrm>
-      </p:grpSpPr>
+      <p:grpSpPr/>
       <p:sp>
         <p:nvSpPr>
           <p:cNvPr id="2" name="Rectangle 1"/>
@@ -7646,26 +7439,61 @@
           <a:lstStyle/>
           <a:p>
             <a:pPr algn="ctr"/>
-            <a:endParaRPr/>
-          </a:p>
-        </p:txBody>
-      </p:sp>
-      <p:sp>
-        <p:nvSpPr>
-          <p:cNvPr id="3" name="Rectangle 2"/>
+          </a:p>
+        </p:txBody>
+      </p:sp>
+      <p:sp>
+        <p:nvSpPr>
+          <p:cNvPr id="3" name="TextBox 2"/>
+          <p:cNvSpPr txBox="1"/>
+          <p:nvPr/>
+        </p:nvSpPr>
+        <p:spPr>
+          <a:xfrm>
+            <a:off x="731520" y="548640"/>
+            <a:ext cx="10515600" cy="731520"/>
+          </a:xfrm>
+          <a:prstGeom prst="rect">
+            <a:avLst/>
+          </a:prstGeom>
+          <a:noFill/>
+        </p:spPr>
+        <p:txBody>
+          <a:bodyPr wrap="none">
+            <a:spAutoFit/>
+          </a:bodyPr>
+          <a:lstStyle/>
+          <a:p>
+            <a:pPr>
+              <a:defRPr sz="3600" b="1">
+                <a:solidFill>
+                  <a:srgbClr val="E6E6E1"/>
+                </a:solidFill>
+                <a:latin typeface="Arial"/>
+              </a:defRPr>
+            </a:pPr>
+            <a:r>
+              <a:t>Agentic Engineering</a:t>
+            </a:r>
+          </a:p>
+        </p:txBody>
+      </p:sp>
+      <p:sp>
+        <p:nvSpPr>
+          <p:cNvPr id="4" name="Rectangle 3"/>
           <p:cNvSpPr/>
           <p:nvPr/>
         </p:nvSpPr>
         <p:spPr>
           <a:xfrm>
-            <a:off x="914400" y="1828800"/>
-            <a:ext cx="73152" cy="2743200"/>
+            <a:off x="731520" y="1280160"/>
+            <a:ext cx="2743200" cy="18288"/>
           </a:xfrm>
           <a:prstGeom prst="rect">
             <a:avLst/>
           </a:prstGeom>
           <a:solidFill>
-            <a:srgbClr val="737370"/>
+            <a:srgbClr val="454543"/>
           </a:solidFill>
           <a:ln>
             <a:noFill/>
@@ -7690,20 +7518,19 @@
           <a:lstStyle/>
           <a:p>
             <a:pPr algn="ctr"/>
-            <a:endParaRPr/>
-          </a:p>
-        </p:txBody>
-      </p:sp>
-      <p:sp>
-        <p:nvSpPr>
-          <p:cNvPr id="4" name="TextBox 3"/>
+          </a:p>
+        </p:txBody>
+      </p:sp>
+      <p:sp>
+        <p:nvSpPr>
+          <p:cNvPr id="5" name="TextBox 4"/>
           <p:cNvSpPr txBox="1"/>
           <p:nvPr/>
         </p:nvSpPr>
         <p:spPr>
           <a:xfrm>
-            <a:off x="1371600" y="1828800"/>
-            <a:ext cx="9601200" cy="2286000"/>
+            <a:off x="731520" y="1645920"/>
+            <a:ext cx="10515600" cy="5029200"/>
           </a:xfrm>
           <a:prstGeom prst="rect">
             <a:avLst/>
@@ -7717,7 +7544,10 @@
           <a:lstStyle/>
           <a:p>
             <a:pPr>
-              <a:defRPr sz="3200" i="1">
+              <a:spcBef>
+                <a:spcPts val="1200"/>
+              </a:spcBef>
+              <a:defRPr sz="1800">
                 <a:solidFill>
                   <a:srgbClr val="CFCFCA"/>
                 </a:solidFill>
@@ -7725,43 +7555,92 @@
               </a:defRPr>
             </a:pPr>
             <a:r>
-              <a:t>"There's a gap between 'AI helped me write this function' and 'AI systematically delivered this feature.' That gap has a name."</a:t>
-            </a:r>
-          </a:p>
-        </p:txBody>
-      </p:sp>
-      <p:sp>
-        <p:nvSpPr>
-          <p:cNvPr id="5" name="TextBox 4"/>
-          <p:cNvSpPr txBox="1"/>
-          <p:nvPr/>
-        </p:nvSpPr>
-        <p:spPr>
-          <a:xfrm>
-            <a:off x="1371600" y="4572000"/>
-            <a:ext cx="9601200" cy="457200"/>
-          </a:xfrm>
-          <a:prstGeom prst="rect">
-            <a:avLst/>
-          </a:prstGeom>
-          <a:noFill/>
-        </p:spPr>
-        <p:txBody>
-          <a:bodyPr wrap="none">
-            <a:spAutoFit/>
-          </a:bodyPr>
-          <a:lstStyle/>
+              <a:t>This is NOT 'AI-assisted development'</a:t>
+            </a:r>
+          </a:p>
           <a:p>
             <a:pPr>
-              <a:defRPr sz="1400">
-                <a:solidFill>
-                  <a:srgbClr val="737370"/>
+              <a:spcBef>
+                <a:spcPts val="600"/>
+              </a:spcBef>
+            </a:pPr>
+          </a:p>
+          <a:p>
+            <a:pPr>
+              <a:spcBef>
+                <a:spcPts val="1200"/>
+              </a:spcBef>
+              <a:defRPr sz="1800">
+                <a:solidFill>
+                  <a:srgbClr val="CFCFCA"/>
                 </a:solidFill>
                 <a:latin typeface="Arial"/>
               </a:defRPr>
             </a:pPr>
             <a:r>
-              <a:t>— AGENTIC ENGINEERING</a:t>
+              <a:t>AI-assisted: Human writes code, AI suggests completions</a:t>
+            </a:r>
+          </a:p>
+          <a:p>
+            <a:pPr>
+              <a:spcBef>
+                <a:spcPts val="1200"/>
+              </a:spcBef>
+              <a:defRPr sz="1800">
+                <a:solidFill>
+                  <a:srgbClr val="CFCFCA"/>
+                </a:solidFill>
+                <a:latin typeface="Arial"/>
+              </a:defRPr>
+            </a:pPr>
+            <a:r>
+              <a:t>Agentic: AI agents execute engineering tasks autonomously</a:t>
+            </a:r>
+          </a:p>
+          <a:p>
+            <a:pPr>
+              <a:spcBef>
+                <a:spcPts val="600"/>
+              </a:spcBef>
+            </a:pPr>
+          </a:p>
+          <a:p>
+            <a:pPr>
+              <a:spcBef>
+                <a:spcPts val="1200"/>
+              </a:spcBef>
+              <a:defRPr sz="1800">
+                <a:solidFill>
+                  <a:srgbClr val="CFCFCA"/>
+                </a:solidFill>
+                <a:latin typeface="Arial"/>
+              </a:defRPr>
+            </a:pPr>
+            <a:r>
+              <a:t>Agents do the work. Humans set the direction.</a:t>
+            </a:r>
+          </a:p>
+          <a:p>
+            <a:pPr>
+              <a:spcBef>
+                <a:spcPts val="600"/>
+              </a:spcBef>
+            </a:pPr>
+          </a:p>
+          <a:p>
+            <a:pPr>
+              <a:spcBef>
+                <a:spcPts val="1200"/>
+              </a:spcBef>
+              <a:defRPr sz="1800">
+                <a:solidFill>
+                  <a:srgbClr val="CFCFCA"/>
+                </a:solidFill>
+                <a:latin typeface="Arial"/>
+              </a:defRPr>
+            </a:pPr>
+            <a:r>
+              <a:t>Fixed price per delivery. No rates. No surprises.</a:t>
             </a:r>
           </a:p>
         </p:txBody>
@@ -7775,7 +7654,7 @@
 </file>
 
 <file path=ppt/slides/slide27.xml><?xml version="1.0" encoding="utf-8"?>
-<p:sld xmlns:a="http://schemas.openxmlformats.org/drawingml/2006/main" xmlns:r="http://schemas.openxmlformats.org/officeDocument/2006/relationships" xmlns:p="http://schemas.openxmlformats.org/presentationml/2006/main">
+<p:sld xmlns:a="http://schemas.openxmlformats.org/drawingml/2006/main" xmlns:p="http://schemas.openxmlformats.org/presentationml/2006/main" xmlns:r="http://schemas.openxmlformats.org/officeDocument/2006/relationships">
   <p:cSld>
     <p:spTree>
       <p:nvGrpSpPr>
@@ -7783,14 +7662,7 @@
         <p:cNvGrpSpPr/>
         <p:nvPr/>
       </p:nvGrpSpPr>
-      <p:grpSpPr>
-        <a:xfrm>
-          <a:off x="0" y="0"/>
-          <a:ext cx="0" cy="0"/>
-          <a:chOff x="0" y="0"/>
-          <a:chExt cx="0" cy="0"/>
-        </a:xfrm>
-      </p:grpSpPr>
+      <p:grpSpPr/>
       <p:sp>
         <p:nvSpPr>
           <p:cNvPr id="2" name="Rectangle 1"/>
@@ -7831,7 +7703,182 @@
           <a:lstStyle/>
           <a:p>
             <a:pPr algn="ctr"/>
-            <a:endParaRPr/>
+          </a:p>
+        </p:txBody>
+      </p:sp>
+      <p:sp>
+        <p:nvSpPr>
+          <p:cNvPr id="3" name="Rectangle 2"/>
+          <p:cNvSpPr/>
+          <p:nvPr/>
+        </p:nvSpPr>
+        <p:spPr>
+          <a:xfrm>
+            <a:off x="914400" y="1828800"/>
+            <a:ext cx="73152" cy="2743200"/>
+          </a:xfrm>
+          <a:prstGeom prst="rect">
+            <a:avLst/>
+          </a:prstGeom>
+          <a:solidFill>
+            <a:srgbClr val="737370"/>
+          </a:solidFill>
+          <a:ln>
+            <a:noFill/>
+          </a:ln>
+        </p:spPr>
+        <p:style>
+          <a:lnRef idx="1">
+            <a:schemeClr val="accent1"/>
+          </a:lnRef>
+          <a:fillRef idx="3">
+            <a:schemeClr val="accent1"/>
+          </a:fillRef>
+          <a:effectRef idx="2">
+            <a:schemeClr val="accent1"/>
+          </a:effectRef>
+          <a:fontRef idx="minor">
+            <a:schemeClr val="lt1"/>
+          </a:fontRef>
+        </p:style>
+        <p:txBody>
+          <a:bodyPr rtlCol="0" anchor="ctr"/>
+          <a:lstStyle/>
+          <a:p>
+            <a:pPr algn="ctr"/>
+          </a:p>
+        </p:txBody>
+      </p:sp>
+      <p:sp>
+        <p:nvSpPr>
+          <p:cNvPr id="4" name="TextBox 3"/>
+          <p:cNvSpPr txBox="1"/>
+          <p:nvPr/>
+        </p:nvSpPr>
+        <p:spPr>
+          <a:xfrm>
+            <a:off x="1371600" y="1828800"/>
+            <a:ext cx="9601200" cy="2286000"/>
+          </a:xfrm>
+          <a:prstGeom prst="rect">
+            <a:avLst/>
+          </a:prstGeom>
+          <a:noFill/>
+        </p:spPr>
+        <p:txBody>
+          <a:bodyPr wrap="square">
+            <a:spAutoFit/>
+          </a:bodyPr>
+          <a:lstStyle/>
+          <a:p>
+            <a:pPr>
+              <a:defRPr sz="3200" i="1">
+                <a:solidFill>
+                  <a:srgbClr val="CFCFCA"/>
+                </a:solidFill>
+                <a:latin typeface="Arial"/>
+              </a:defRPr>
+            </a:pPr>
+            <a:r>
+              <a:t>"Agents do the work. Humans set the direction. That's Agentic Engineering."</a:t>
+            </a:r>
+          </a:p>
+        </p:txBody>
+      </p:sp>
+      <p:sp>
+        <p:nvSpPr>
+          <p:cNvPr id="5" name="TextBox 4"/>
+          <p:cNvSpPr txBox="1"/>
+          <p:nvPr/>
+        </p:nvSpPr>
+        <p:spPr>
+          <a:xfrm>
+            <a:off x="1371600" y="4572000"/>
+            <a:ext cx="9601200" cy="457200"/>
+          </a:xfrm>
+          <a:prstGeom prst="rect">
+            <a:avLst/>
+          </a:prstGeom>
+          <a:noFill/>
+        </p:spPr>
+        <p:txBody>
+          <a:bodyPr wrap="none">
+            <a:spAutoFit/>
+          </a:bodyPr>
+          <a:lstStyle/>
+          <a:p>
+            <a:pPr>
+              <a:defRPr sz="1400">
+                <a:solidFill>
+                  <a:srgbClr val="737370"/>
+                </a:solidFill>
+                <a:latin typeface="Arial"/>
+              </a:defRPr>
+            </a:pPr>
+            <a:r>
+              <a:t>— AGENTIC AGENCY</a:t>
+            </a:r>
+          </a:p>
+        </p:txBody>
+      </p:sp>
+    </p:spTree>
+  </p:cSld>
+  <p:clrMapOvr>
+    <a:masterClrMapping/>
+  </p:clrMapOvr>
+</p:sld>
+</file>
+
+<file path=ppt/slides/slide28.xml><?xml version="1.0" encoding="utf-8"?>
+<p:sld xmlns:a="http://schemas.openxmlformats.org/drawingml/2006/main" xmlns:p="http://schemas.openxmlformats.org/presentationml/2006/main" xmlns:r="http://schemas.openxmlformats.org/officeDocument/2006/relationships">
+  <p:cSld>
+    <p:spTree>
+      <p:nvGrpSpPr>
+        <p:cNvPr id="1" name=""/>
+        <p:cNvGrpSpPr/>
+        <p:nvPr/>
+      </p:nvGrpSpPr>
+      <p:grpSpPr/>
+      <p:sp>
+        <p:nvSpPr>
+          <p:cNvPr id="2" name="Rectangle 1"/>
+          <p:cNvSpPr/>
+          <p:nvPr/>
+        </p:nvSpPr>
+        <p:spPr>
+          <a:xfrm>
+            <a:off x="0" y="0"/>
+            <a:ext cx="12191695" cy="6858000"/>
+          </a:xfrm>
+          <a:prstGeom prst="rect">
+            <a:avLst/>
+          </a:prstGeom>
+          <a:solidFill>
+            <a:srgbClr val="000000"/>
+          </a:solidFill>
+          <a:ln>
+            <a:noFill/>
+          </a:ln>
+        </p:spPr>
+        <p:style>
+          <a:lnRef idx="1">
+            <a:schemeClr val="accent1"/>
+          </a:lnRef>
+          <a:fillRef idx="3">
+            <a:schemeClr val="accent1"/>
+          </a:fillRef>
+          <a:effectRef idx="2">
+            <a:schemeClr val="accent1"/>
+          </a:effectRef>
+          <a:fontRef idx="minor">
+            <a:schemeClr val="lt1"/>
+          </a:fontRef>
+        </p:style>
+        <p:txBody>
+          <a:bodyPr rtlCol="0" anchor="ctr"/>
+          <a:lstStyle/>
+          <a:p>
+            <a:pPr algn="ctr"/>
           </a:p>
         </p:txBody>
       </p:sp>
@@ -7875,7 +7922,6 @@
           <a:lstStyle/>
           <a:p>
             <a:pPr algn="ctr"/>
-            <a:endParaRPr/>
           </a:p>
         </p:txBody>
       </p:sp>
@@ -7919,7 +7965,6 @@
           <a:lstStyle/>
           <a:p>
             <a:pPr algn="ctr"/>
-            <a:endParaRPr/>
           </a:p>
         </p:txBody>
       </p:sp>
@@ -8040,7 +8085,7 @@
 </file>
 
 <file path=ppt/slides/slide3.xml><?xml version="1.0" encoding="utf-8"?>
-<p:sld xmlns:a="http://schemas.openxmlformats.org/drawingml/2006/main" xmlns:r="http://schemas.openxmlformats.org/officeDocument/2006/relationships" xmlns:p="http://schemas.openxmlformats.org/presentationml/2006/main">
+<p:sld xmlns:a="http://schemas.openxmlformats.org/drawingml/2006/main" xmlns:p="http://schemas.openxmlformats.org/presentationml/2006/main" xmlns:r="http://schemas.openxmlformats.org/officeDocument/2006/relationships">
   <p:cSld>
     <p:spTree>
       <p:nvGrpSpPr>
@@ -8048,14 +8093,7 @@
         <p:cNvGrpSpPr/>
         <p:nvPr/>
       </p:nvGrpSpPr>
-      <p:grpSpPr>
-        <a:xfrm>
-          <a:off x="0" y="0"/>
-          <a:ext cx="0" cy="0"/>
-          <a:chOff x="0" y="0"/>
-          <a:chExt cx="0" cy="0"/>
-        </a:xfrm>
-      </p:grpSpPr>
+      <p:grpSpPr/>
       <p:sp>
         <p:nvSpPr>
           <p:cNvPr id="2" name="Rectangle 1"/>
@@ -8096,7 +8134,6 @@
           <a:lstStyle/>
           <a:p>
             <a:pPr algn="ctr"/>
-            <a:endParaRPr/>
           </a:p>
         </p:txBody>
       </p:sp>
@@ -8176,7 +8213,6 @@
           <a:lstStyle/>
           <a:p>
             <a:pPr algn="ctr"/>
-            <a:endParaRPr/>
           </a:p>
         </p:txBody>
       </p:sp>
@@ -8223,7 +8259,6 @@
                 <a:spcPts val="600"/>
               </a:spcBef>
             </a:pPr>
-            <a:endParaRPr/>
           </a:p>
           <a:p>
             <a:pPr>
@@ -8247,7 +8282,6 @@
                 <a:spcPts val="600"/>
               </a:spcBef>
             </a:pPr>
-            <a:endParaRPr/>
           </a:p>
           <a:p>
             <a:pPr>
@@ -8292,7 +8326,7 @@
 </file>
 
 <file path=ppt/slides/slide4.xml><?xml version="1.0" encoding="utf-8"?>
-<p:sld xmlns:a="http://schemas.openxmlformats.org/drawingml/2006/main" xmlns:r="http://schemas.openxmlformats.org/officeDocument/2006/relationships" xmlns:p="http://schemas.openxmlformats.org/presentationml/2006/main">
+<p:sld xmlns:a="http://schemas.openxmlformats.org/drawingml/2006/main" xmlns:p="http://schemas.openxmlformats.org/presentationml/2006/main" xmlns:r="http://schemas.openxmlformats.org/officeDocument/2006/relationships">
   <p:cSld>
     <p:spTree>
       <p:nvGrpSpPr>
@@ -8300,14 +8334,7 @@
         <p:cNvGrpSpPr/>
         <p:nvPr/>
       </p:nvGrpSpPr>
-      <p:grpSpPr>
-        <a:xfrm>
-          <a:off x="0" y="0"/>
-          <a:ext cx="0" cy="0"/>
-          <a:chOff x="0" y="0"/>
-          <a:chExt cx="0" cy="0"/>
-        </a:xfrm>
-      </p:grpSpPr>
+      <p:grpSpPr/>
       <p:sp>
         <p:nvSpPr>
           <p:cNvPr id="2" name="Rectangle 1"/>
@@ -8348,7 +8375,6 @@
           <a:lstStyle/>
           <a:p>
             <a:pPr algn="ctr"/>
-            <a:endParaRPr/>
           </a:p>
         </p:txBody>
       </p:sp>
@@ -8428,7 +8454,6 @@
           <a:lstStyle/>
           <a:p>
             <a:pPr algn="ctr"/>
-            <a:endParaRPr/>
           </a:p>
         </p:txBody>
       </p:sp>
@@ -8451,20 +8476,8 @@
                 <a:tableStyleId>{5C22544A-7EE6-4342-B048-85BDC9FD1C3A}</a:tableStyleId>
               </a:tblPr>
               <a:tblGrid>
-                <a:gridCol w="5257800">
-                  <a:extLst>
-                    <a:ext uri="{9D8B030D-6E8A-4147-A177-3AD203B41FA5}">
-                      <a16:colId xmlns:a16="http://schemas.microsoft.com/office/drawing/2014/main" val="20000"/>
-                    </a:ext>
-                  </a:extLst>
-                </a:gridCol>
-                <a:gridCol w="5257800">
-                  <a:extLst>
-                    <a:ext uri="{9D8B030D-6E8A-4147-A177-3AD203B41FA5}">
-                      <a16:colId xmlns:a16="http://schemas.microsoft.com/office/drawing/2014/main" val="20001"/>
-                    </a:ext>
-                  </a:extLst>
-                </a:gridCol>
+                <a:gridCol w="5257800"/>
+                <a:gridCol w="5257800"/>
               </a:tblGrid>
               <a:tr h="548639">
                 <a:tc>
@@ -8473,7 +8486,7 @@
                     <a:lstStyle/>
                     <a:p>
                       <a:pPr>
-                        <a:defRPr sz="1400" b="1">
+                        <a:defRPr b="1" sz="1400">
                           <a:solidFill>
                             <a:srgbClr val="000000"/>
                           </a:solidFill>
@@ -8497,7 +8510,7 @@
                     <a:lstStyle/>
                     <a:p>
                       <a:pPr>
-                        <a:defRPr sz="1400" b="1">
+                        <a:defRPr b="1" sz="1400">
                           <a:solidFill>
                             <a:srgbClr val="000000"/>
                           </a:solidFill>
@@ -8515,11 +8528,6 @@
                     </a:solidFill>
                   </a:tcPr>
                 </a:tc>
-                <a:extLst>
-                  <a:ext uri="{0D108BD9-81ED-4DB2-BD59-A6C34878D82A}">
-                    <a16:rowId xmlns:a16="http://schemas.microsoft.com/office/drawing/2014/main" val="10000"/>
-                  </a:ext>
-                </a:extLst>
               </a:tr>
               <a:tr h="548639">
                 <a:tc>
@@ -8570,11 +8578,6 @@
                     </a:solidFill>
                   </a:tcPr>
                 </a:tc>
-                <a:extLst>
-                  <a:ext uri="{0D108BD9-81ED-4DB2-BD59-A6C34878D82A}">
-                    <a16:rowId xmlns:a16="http://schemas.microsoft.com/office/drawing/2014/main" val="10001"/>
-                  </a:ext>
-                </a:extLst>
               </a:tr>
               <a:tr h="548639">
                 <a:tc>
@@ -8625,11 +8628,6 @@
                     </a:solidFill>
                   </a:tcPr>
                 </a:tc>
-                <a:extLst>
-                  <a:ext uri="{0D108BD9-81ED-4DB2-BD59-A6C34878D82A}">
-                    <a16:rowId xmlns:a16="http://schemas.microsoft.com/office/drawing/2014/main" val="10002"/>
-                  </a:ext>
-                </a:extLst>
               </a:tr>
               <a:tr h="548639">
                 <a:tc>
@@ -8680,11 +8678,6 @@
                     </a:solidFill>
                   </a:tcPr>
                 </a:tc>
-                <a:extLst>
-                  <a:ext uri="{0D108BD9-81ED-4DB2-BD59-A6C34878D82A}">
-                    <a16:rowId xmlns:a16="http://schemas.microsoft.com/office/drawing/2014/main" val="10003"/>
-                  </a:ext>
-                </a:extLst>
               </a:tr>
               <a:tr h="548639">
                 <a:tc>
@@ -8735,11 +8728,6 @@
                     </a:solidFill>
                   </a:tcPr>
                 </a:tc>
-                <a:extLst>
-                  <a:ext uri="{0D108BD9-81ED-4DB2-BD59-A6C34878D82A}">
-                    <a16:rowId xmlns:a16="http://schemas.microsoft.com/office/drawing/2014/main" val="10004"/>
-                  </a:ext>
-                </a:extLst>
               </a:tr>
               <a:tr h="548644">
                 <a:tc>
@@ -8790,11 +8778,6 @@
                     </a:solidFill>
                   </a:tcPr>
                 </a:tc>
-                <a:extLst>
-                  <a:ext uri="{0D108BD9-81ED-4DB2-BD59-A6C34878D82A}">
-                    <a16:rowId xmlns:a16="http://schemas.microsoft.com/office/drawing/2014/main" val="10005"/>
-                  </a:ext>
-                </a:extLst>
               </a:tr>
             </a:tbl>
           </a:graphicData>
@@ -8809,7 +8792,7 @@
 </file>
 
 <file path=ppt/slides/slide5.xml><?xml version="1.0" encoding="utf-8"?>
-<p:sld xmlns:a="http://schemas.openxmlformats.org/drawingml/2006/main" xmlns:r="http://schemas.openxmlformats.org/officeDocument/2006/relationships" xmlns:p="http://schemas.openxmlformats.org/presentationml/2006/main">
+<p:sld xmlns:a="http://schemas.openxmlformats.org/drawingml/2006/main" xmlns:p="http://schemas.openxmlformats.org/presentationml/2006/main" xmlns:r="http://schemas.openxmlformats.org/officeDocument/2006/relationships">
   <p:cSld>
     <p:spTree>
       <p:nvGrpSpPr>
@@ -8817,14 +8800,7 @@
         <p:cNvGrpSpPr/>
         <p:nvPr/>
       </p:nvGrpSpPr>
-      <p:grpSpPr>
-        <a:xfrm>
-          <a:off x="0" y="0"/>
-          <a:ext cx="0" cy="0"/>
-          <a:chOff x="0" y="0"/>
-          <a:chExt cx="0" cy="0"/>
-        </a:xfrm>
-      </p:grpSpPr>
+      <p:grpSpPr/>
       <p:sp>
         <p:nvSpPr>
           <p:cNvPr id="2" name="Rectangle 1"/>
@@ -8865,7 +8841,6 @@
           <a:lstStyle/>
           <a:p>
             <a:pPr algn="ctr"/>
-            <a:endParaRPr/>
           </a:p>
         </p:txBody>
       </p:sp>
@@ -8981,7 +8956,6 @@
           <a:lstStyle/>
           <a:p>
             <a:pPr algn="ctr"/>
-            <a:endParaRPr/>
           </a:p>
         </p:txBody>
       </p:sp>
@@ -8994,7 +8968,7 @@
 </file>
 
 <file path=ppt/slides/slide6.xml><?xml version="1.0" encoding="utf-8"?>
-<p:sld xmlns:a="http://schemas.openxmlformats.org/drawingml/2006/main" xmlns:r="http://schemas.openxmlformats.org/officeDocument/2006/relationships" xmlns:p="http://schemas.openxmlformats.org/presentationml/2006/main">
+<p:sld xmlns:a="http://schemas.openxmlformats.org/drawingml/2006/main" xmlns:p="http://schemas.openxmlformats.org/presentationml/2006/main" xmlns:r="http://schemas.openxmlformats.org/officeDocument/2006/relationships">
   <p:cSld>
     <p:spTree>
       <p:nvGrpSpPr>
@@ -9002,14 +8976,7 @@
         <p:cNvGrpSpPr/>
         <p:nvPr/>
       </p:nvGrpSpPr>
-      <p:grpSpPr>
-        <a:xfrm>
-          <a:off x="0" y="0"/>
-          <a:ext cx="0" cy="0"/>
-          <a:chOff x="0" y="0"/>
-          <a:chExt cx="0" cy="0"/>
-        </a:xfrm>
-      </p:grpSpPr>
+      <p:grpSpPr/>
       <p:sp>
         <p:nvSpPr>
           <p:cNvPr id="2" name="Rectangle 1"/>
@@ -9050,7 +9017,6 @@
           <a:lstStyle/>
           <a:p>
             <a:pPr algn="ctr"/>
-            <a:endParaRPr/>
           </a:p>
         </p:txBody>
       </p:sp>
@@ -9130,7 +9096,6 @@
           <a:lstStyle/>
           <a:p>
             <a:pPr algn="ctr"/>
-            <a:endParaRPr/>
           </a:p>
         </p:txBody>
       </p:sp>
@@ -9174,7 +9139,6 @@
           <a:lstStyle/>
           <a:p>
             <a:pPr algn="ctr"/>
-            <a:endParaRPr/>
           </a:p>
         </p:txBody>
       </p:sp>
@@ -9194,8 +9158,8 @@
         </p:blipFill>
         <p:spPr>
           <a:xfrm>
-            <a:off x="2264214" y="1333455"/>
-            <a:ext cx="6376465" cy="4191090"/>
+            <a:off x="548640" y="1005840"/>
+            <a:ext cx="10972800" cy="7212145"/>
           </a:xfrm>
           <a:prstGeom prst="rect">
             <a:avLst/>
@@ -9247,7 +9211,7 @@
 </file>
 
 <file path=ppt/slides/slide7.xml><?xml version="1.0" encoding="utf-8"?>
-<p:sld xmlns:a="http://schemas.openxmlformats.org/drawingml/2006/main" xmlns:r="http://schemas.openxmlformats.org/officeDocument/2006/relationships" xmlns:p="http://schemas.openxmlformats.org/presentationml/2006/main">
+<p:sld xmlns:a="http://schemas.openxmlformats.org/drawingml/2006/main" xmlns:p="http://schemas.openxmlformats.org/presentationml/2006/main" xmlns:r="http://schemas.openxmlformats.org/officeDocument/2006/relationships">
   <p:cSld>
     <p:spTree>
       <p:nvGrpSpPr>
@@ -9255,14 +9219,7 @@
         <p:cNvGrpSpPr/>
         <p:nvPr/>
       </p:nvGrpSpPr>
-      <p:grpSpPr>
-        <a:xfrm>
-          <a:off x="0" y="0"/>
-          <a:ext cx="0" cy="0"/>
-          <a:chOff x="0" y="0"/>
-          <a:chExt cx="0" cy="0"/>
-        </a:xfrm>
-      </p:grpSpPr>
+      <p:grpSpPr/>
       <p:sp>
         <p:nvSpPr>
           <p:cNvPr id="2" name="Rectangle 1"/>
@@ -9303,7 +9260,6 @@
           <a:lstStyle/>
           <a:p>
             <a:pPr algn="ctr"/>
-            <a:endParaRPr/>
           </a:p>
         </p:txBody>
       </p:sp>
@@ -9383,7 +9339,6 @@
           <a:lstStyle/>
           <a:p>
             <a:pPr algn="ctr"/>
-            <a:endParaRPr/>
           </a:p>
         </p:txBody>
       </p:sp>
@@ -9427,7 +9382,6 @@
           <a:lstStyle/>
           <a:p>
             <a:pPr algn="ctr"/>
-            <a:endParaRPr/>
           </a:p>
         </p:txBody>
       </p:sp>
@@ -9447,8 +9401,8 @@
         </p:blipFill>
         <p:spPr>
           <a:xfrm>
-            <a:off x="1911816" y="1097280"/>
-            <a:ext cx="7742547" cy="4692356"/>
+            <a:off x="548640" y="1005840"/>
+            <a:ext cx="10972800" cy="6650044"/>
           </a:xfrm>
           <a:prstGeom prst="rect">
             <a:avLst/>
@@ -9500,7 +9454,7 @@
 </file>
 
 <file path=ppt/slides/slide8.xml><?xml version="1.0" encoding="utf-8"?>
-<p:sld xmlns:a="http://schemas.openxmlformats.org/drawingml/2006/main" xmlns:r="http://schemas.openxmlformats.org/officeDocument/2006/relationships" xmlns:p="http://schemas.openxmlformats.org/presentationml/2006/main">
+<p:sld xmlns:a="http://schemas.openxmlformats.org/drawingml/2006/main" xmlns:p="http://schemas.openxmlformats.org/presentationml/2006/main" xmlns:r="http://schemas.openxmlformats.org/officeDocument/2006/relationships">
   <p:cSld>
     <p:spTree>
       <p:nvGrpSpPr>
@@ -9508,14 +9462,7 @@
         <p:cNvGrpSpPr/>
         <p:nvPr/>
       </p:nvGrpSpPr>
-      <p:grpSpPr>
-        <a:xfrm>
-          <a:off x="0" y="0"/>
-          <a:ext cx="0" cy="0"/>
-          <a:chOff x="0" y="0"/>
-          <a:chExt cx="0" cy="0"/>
-        </a:xfrm>
-      </p:grpSpPr>
+      <p:grpSpPr/>
       <p:sp>
         <p:nvSpPr>
           <p:cNvPr id="2" name="Rectangle 1"/>
@@ -9556,7 +9503,6 @@
           <a:lstStyle/>
           <a:p>
             <a:pPr algn="ctr"/>
-            <a:endParaRPr/>
           </a:p>
         </p:txBody>
       </p:sp>
@@ -9672,7 +9618,6 @@
           <a:lstStyle/>
           <a:p>
             <a:pPr algn="ctr"/>
-            <a:endParaRPr/>
           </a:p>
         </p:txBody>
       </p:sp>
@@ -9685,7 +9630,7 @@
 </file>
 
 <file path=ppt/slides/slide9.xml><?xml version="1.0" encoding="utf-8"?>
-<p:sld xmlns:a="http://schemas.openxmlformats.org/drawingml/2006/main" xmlns:r="http://schemas.openxmlformats.org/officeDocument/2006/relationships" xmlns:p="http://schemas.openxmlformats.org/presentationml/2006/main">
+<p:sld xmlns:a="http://schemas.openxmlformats.org/drawingml/2006/main" xmlns:p="http://schemas.openxmlformats.org/presentationml/2006/main" xmlns:r="http://schemas.openxmlformats.org/officeDocument/2006/relationships">
   <p:cSld>
     <p:spTree>
       <p:nvGrpSpPr>
@@ -9693,14 +9638,7 @@
         <p:cNvGrpSpPr/>
         <p:nvPr/>
       </p:nvGrpSpPr>
-      <p:grpSpPr>
-        <a:xfrm>
-          <a:off x="0" y="0"/>
-          <a:ext cx="0" cy="0"/>
-          <a:chOff x="0" y="0"/>
-          <a:chExt cx="0" cy="0"/>
-        </a:xfrm>
-      </p:grpSpPr>
+      <p:grpSpPr/>
       <p:sp>
         <p:nvSpPr>
           <p:cNvPr id="2" name="Rectangle 1"/>
@@ -9741,7 +9679,6 @@
           <a:lstStyle/>
           <a:p>
             <a:pPr algn="ctr"/>
-            <a:endParaRPr/>
           </a:p>
         </p:txBody>
       </p:sp>
@@ -9821,7 +9758,6 @@
           <a:lstStyle/>
           <a:p>
             <a:pPr algn="ctr"/>
-            <a:endParaRPr/>
           </a:p>
         </p:txBody>
       </p:sp>
@@ -9865,7 +9801,6 @@
           <a:lstStyle/>
           <a:p>
             <a:pPr algn="ctr"/>
-            <a:endParaRPr/>
           </a:p>
         </p:txBody>
       </p:sp>
@@ -9885,8 +9820,8 @@
         </p:blipFill>
         <p:spPr>
           <a:xfrm>
-            <a:off x="1516025" y="2371976"/>
-            <a:ext cx="9159949" cy="2114048"/>
+            <a:off x="548640" y="1005840"/>
+            <a:ext cx="10972800" cy="2532440"/>
           </a:xfrm>
           <a:prstGeom prst="rect">
             <a:avLst/>

</xml_diff>